<commit_message>
Paso W-4: Regenerar binarios de Semana 5 (Tablero Kanban, MoSCoW y Puño de Cinco en HTML/PPTX/PDF)
</commit_message>
<xml_diff>
--- a/curso/semana-05-rsu-y-backlog/nuestras-entregas/Presentacion_Fist_of_Five/Presentacion_Fist_of_Five.pptx
+++ b/curso/semana-05-rsu-y-backlog/nuestras-entregas/Presentacion_Fist_of_Five/Presentacion_Fist_of_Five.pptx
@@ -949,7 +949,7 @@
           <a:p>
             <a:r>
               <a:rPr lang="en-US" dirty="0"/>
-              <a:t>Anthony. Aplicamos el puño de cinco a nuestras doce historias de usuario. Cada número es el tamaño acordado después de votar y de que los extremos explicaran su razón. La más grande es la HU07, procesar el clip con ConvLSTM, que vimos en el ejemplo anterior. Las de carga y configuración son pequeñas. Son votos simulados por el equipo; los reales se toman en la planificación de cada sprint.</a:t>
+              <a:t>Anthony. Aplicamos el puño de cinco a nuestras doce historias de usuario. Cada número es el tamaño acordado después de votar y de que los extremos explicaran su razón. La más grande es la HU07, procesar el clip con ConvLSTM, que vimos en el ejemplo anterior. Las de carga y configuración son pequeñas. Los puntos se calibran para 4 sprints equilibrados de unos 8 puntos.</a:t>
             </a:r>
             <a:endParaRPr lang="en-US" dirty="0"/>
           </a:p>
@@ -7926,7 +7926,7 @@
                 <a:ea typeface="Calibri" pitchFamily="34" charset="-122"/>
                 <a:cs typeface="Calibri" pitchFamily="34" charset="-120"/>
               </a:rPr>
-              <a:t>Detectar trabajadores con YOLOv4</a:t>
+              <a:t>Detectar operarios con YOLOv8</a:t>
             </a:r>
             <a:endParaRPr lang="en-US" sz="1100" dirty="0"/>
           </a:p>
@@ -7941,6 +7941,360 @@
         <p:spPr>
           <a:xfrm>
             <a:off x="6035040" y="1600200"/>
+            <a:ext cx="402336" cy="402336"/>
+          </a:xfrm>
+          <a:prstGeom prst="roundRect">
+            <a:avLst>
+              <a:gd name="adj" fmla="val 50000"/>
+            </a:avLst>
+          </a:prstGeom>
+          <a:solidFill>
+            <a:srgbClr val="F2643D">
+              <a:alpha val="85000"/>
+            </a:srgbClr>
+          </a:solidFill>
+          <a:ln/>
+        </p:spPr>
+      </p:sp>
+      <p:sp>
+        <p:nvSpPr>
+          <p:cNvPr id="18" name="obj187"/>
+          <p:cNvSpPr txBox="1"/>
+          <p:nvPr/>
+        </p:nvSpPr>
+        <p:spPr>
+          <a:xfrm>
+            <a:off x="6035040" y="1600200"/>
+            <a:ext cx="402336" cy="402336"/>
+          </a:xfrm>
+          <a:prstGeom prst="rect">
+            <a:avLst/>
+          </a:prstGeom>
+          <a:noFill/>
+          <a:ln/>
+        </p:spPr>
+        <p:txBody>
+          <a:bodyPr wrap="square" lIns="0" tIns="0" rIns="0" bIns="0" rtlCol="0" anchor="ctr"/>
+          <a:lstStyle/>
+          <a:p>
+            <a:pPr algn="ctr" indent="0" marL="0">
+              <a:buNone/>
+            </a:pPr>
+            <a:r>
+              <a:rPr lang="en-US" sz="1600" b="1" dirty="0">
+                <a:solidFill>
+                  <a:srgbClr val="FFFFFF"/>
+                </a:solidFill>
+                <a:latin typeface="Calibri" pitchFamily="34" charset="0"/>
+                <a:ea typeface="Calibri" pitchFamily="34" charset="-122"/>
+                <a:cs typeface="Calibri" pitchFamily="34" charset="-120"/>
+              </a:rPr>
+              <a:t>4</a:t>
+            </a:r>
+            <a:endParaRPr lang="en-US" sz="1600" dirty="0"/>
+          </a:p>
+        </p:txBody>
+      </p:sp>
+      <p:sp>
+        <p:nvSpPr>
+          <p:cNvPr id="19" name="obj188"/>
+          <p:cNvSpPr/>
+          <p:nvPr/>
+        </p:nvSpPr>
+        <p:spPr>
+          <a:xfrm>
+            <a:off x="6720840" y="1371600"/>
+            <a:ext cx="1874520" cy="914400"/>
+          </a:xfrm>
+          <a:prstGeom prst="roundRect">
+            <a:avLst>
+              <a:gd name="adj" fmla="val 14000"/>
+            </a:avLst>
+          </a:prstGeom>
+          <a:solidFill>
+            <a:srgbClr val="F4F4F2"/>
+          </a:solidFill>
+          <a:ln/>
+        </p:spPr>
+      </p:sp>
+      <p:sp>
+        <p:nvSpPr>
+          <p:cNvPr id="20" name="obj189"/>
+          <p:cNvSpPr txBox="1"/>
+          <p:nvPr/>
+        </p:nvSpPr>
+        <p:spPr>
+          <a:xfrm>
+            <a:off x="6858000" y="1463040"/>
+            <a:ext cx="1188720" cy="228600"/>
+          </a:xfrm>
+          <a:prstGeom prst="rect">
+            <a:avLst/>
+          </a:prstGeom>
+          <a:noFill/>
+          <a:ln/>
+        </p:spPr>
+        <p:txBody>
+          <a:bodyPr wrap="square" lIns="0" tIns="0" rIns="0" bIns="0" rtlCol="0" anchor="t"/>
+          <a:lstStyle/>
+          <a:p>
+            <a:pPr algn="l" indent="0" marL="0">
+              <a:buNone/>
+            </a:pPr>
+            <a:r>
+              <a:rPr lang="en-US" sz="1100" b="1" dirty="0">
+                <a:solidFill>
+                  <a:srgbClr val="F2643D"/>
+                </a:solidFill>
+                <a:latin typeface="Calibri" pitchFamily="34" charset="0"/>
+                <a:ea typeface="Calibri" pitchFamily="34" charset="-122"/>
+                <a:cs typeface="Calibri" pitchFamily="34" charset="-120"/>
+              </a:rPr>
+              <a:t>HU04</a:t>
+            </a:r>
+            <a:pPr algn="l" indent="0" marL="0">
+              <a:buNone/>
+            </a:pPr>
+            <a:r>
+              <a:rPr lang="en-US" sz="1100" dirty="0">
+                <a:solidFill>
+                  <a:srgbClr val="F2643D"/>
+                </a:solidFill>
+                <a:latin typeface="Calibri" pitchFamily="34" charset="0"/>
+                <a:ea typeface="Calibri" pitchFamily="34" charset="-122"/>
+                <a:cs typeface="Calibri" pitchFamily="34" charset="-120"/>
+              </a:rPr>
+              <a:t> · EP02</a:t>
+            </a:r>
+            <a:endParaRPr lang="en-US" sz="1100" dirty="0"/>
+          </a:p>
+        </p:txBody>
+      </p:sp>
+      <p:sp>
+        <p:nvSpPr>
+          <p:cNvPr id="21" name="obj190"/>
+          <p:cNvSpPr txBox="1"/>
+          <p:nvPr/>
+        </p:nvSpPr>
+        <p:spPr>
+          <a:xfrm>
+            <a:off x="6858000" y="1700784"/>
+            <a:ext cx="1207008" cy="530352"/>
+          </a:xfrm>
+          <a:prstGeom prst="rect">
+            <a:avLst/>
+          </a:prstGeom>
+          <a:noFill/>
+          <a:ln/>
+        </p:spPr>
+        <p:txBody>
+          <a:bodyPr wrap="square" lIns="0" tIns="0" rIns="0" bIns="0" rtlCol="0" anchor="t"/>
+          <a:lstStyle/>
+          <a:p>
+            <a:pPr algn="l" indent="0" marL="0">
+              <a:buNone/>
+            </a:pPr>
+            <a:r>
+              <a:rPr lang="en-US" sz="1100" dirty="0">
+                <a:solidFill>
+                  <a:srgbClr val="1F2421"/>
+                </a:solidFill>
+                <a:latin typeface="Calibri" pitchFamily="34" charset="0"/>
+                <a:ea typeface="Calibri" pitchFamily="34" charset="-122"/>
+                <a:cs typeface="Calibri" pitchFamily="34" charset="-120"/>
+              </a:rPr>
+              <a:t>Descartar frames sin operarios</a:t>
+            </a:r>
+            <a:endParaRPr lang="en-US" sz="1100" dirty="0"/>
+          </a:p>
+        </p:txBody>
+      </p:sp>
+      <p:sp>
+        <p:nvSpPr>
+          <p:cNvPr id="22" name="obj191"/>
+          <p:cNvSpPr/>
+          <p:nvPr/>
+        </p:nvSpPr>
+        <p:spPr>
+          <a:xfrm>
+            <a:off x="8092440" y="1600200"/>
+            <a:ext cx="402336" cy="402336"/>
+          </a:xfrm>
+          <a:prstGeom prst="roundRect">
+            <a:avLst>
+              <a:gd name="adj" fmla="val 50000"/>
+            </a:avLst>
+          </a:prstGeom>
+          <a:solidFill>
+            <a:srgbClr val="F2643D">
+              <a:alpha val="45000"/>
+            </a:srgbClr>
+          </a:solidFill>
+          <a:ln/>
+        </p:spPr>
+      </p:sp>
+      <p:sp>
+        <p:nvSpPr>
+          <p:cNvPr id="23" name="obj192"/>
+          <p:cNvSpPr txBox="1"/>
+          <p:nvPr/>
+        </p:nvSpPr>
+        <p:spPr>
+          <a:xfrm>
+            <a:off x="8092440" y="1600200"/>
+            <a:ext cx="402336" cy="402336"/>
+          </a:xfrm>
+          <a:prstGeom prst="rect">
+            <a:avLst/>
+          </a:prstGeom>
+          <a:noFill/>
+          <a:ln/>
+        </p:spPr>
+        <p:txBody>
+          <a:bodyPr wrap="square" lIns="0" tIns="0" rIns="0" bIns="0" rtlCol="0" anchor="ctr"/>
+          <a:lstStyle/>
+          <a:p>
+            <a:pPr algn="ctr" indent="0" marL="0">
+              <a:buNone/>
+            </a:pPr>
+            <a:r>
+              <a:rPr lang="en-US" sz="1600" b="1" dirty="0">
+                <a:solidFill>
+                  <a:srgbClr val="1F2421"/>
+                </a:solidFill>
+                <a:latin typeface="Calibri" pitchFamily="34" charset="0"/>
+                <a:ea typeface="Calibri" pitchFamily="34" charset="-122"/>
+                <a:cs typeface="Calibri" pitchFamily="34" charset="-120"/>
+              </a:rPr>
+              <a:t>2</a:t>
+            </a:r>
+            <a:endParaRPr lang="en-US" sz="1600" dirty="0"/>
+          </a:p>
+        </p:txBody>
+      </p:sp>
+      <p:sp>
+        <p:nvSpPr>
+          <p:cNvPr id="24" name="obj193"/>
+          <p:cNvSpPr/>
+          <p:nvPr/>
+        </p:nvSpPr>
+        <p:spPr>
+          <a:xfrm>
+            <a:off x="548640" y="2395728"/>
+            <a:ext cx="1874520" cy="914400"/>
+          </a:xfrm>
+          <a:prstGeom prst="roundRect">
+            <a:avLst>
+              <a:gd name="adj" fmla="val 14000"/>
+            </a:avLst>
+          </a:prstGeom>
+          <a:solidFill>
+            <a:srgbClr val="F4F4F2"/>
+          </a:solidFill>
+          <a:ln/>
+        </p:spPr>
+      </p:sp>
+      <p:sp>
+        <p:nvSpPr>
+          <p:cNvPr id="25" name="obj194"/>
+          <p:cNvSpPr txBox="1"/>
+          <p:nvPr/>
+        </p:nvSpPr>
+        <p:spPr>
+          <a:xfrm>
+            <a:off x="685800" y="2487168"/>
+            <a:ext cx="1188720" cy="228600"/>
+          </a:xfrm>
+          <a:prstGeom prst="rect">
+            <a:avLst/>
+          </a:prstGeom>
+          <a:noFill/>
+          <a:ln/>
+        </p:spPr>
+        <p:txBody>
+          <a:bodyPr wrap="square" lIns="0" tIns="0" rIns="0" bIns="0" rtlCol="0" anchor="t"/>
+          <a:lstStyle/>
+          <a:p>
+            <a:pPr algn="l" indent="0" marL="0">
+              <a:buNone/>
+            </a:pPr>
+            <a:r>
+              <a:rPr lang="en-US" sz="1100" b="1" dirty="0">
+                <a:solidFill>
+                  <a:srgbClr val="F2643D"/>
+                </a:solidFill>
+                <a:latin typeface="Calibri" pitchFamily="34" charset="0"/>
+                <a:ea typeface="Calibri" pitchFamily="34" charset="-122"/>
+                <a:cs typeface="Calibri" pitchFamily="34" charset="-120"/>
+              </a:rPr>
+              <a:t>HU05</a:t>
+            </a:r>
+            <a:pPr algn="l" indent="0" marL="0">
+              <a:buNone/>
+            </a:pPr>
+            <a:r>
+              <a:rPr lang="en-US" sz="1100" dirty="0">
+                <a:solidFill>
+                  <a:srgbClr val="F2643D"/>
+                </a:solidFill>
+                <a:latin typeface="Calibri" pitchFamily="34" charset="0"/>
+                <a:ea typeface="Calibri" pitchFamily="34" charset="-122"/>
+                <a:cs typeface="Calibri" pitchFamily="34" charset="-120"/>
+              </a:rPr>
+              <a:t> · EP03</a:t>
+            </a:r>
+            <a:endParaRPr lang="en-US" sz="1100" dirty="0"/>
+          </a:p>
+        </p:txBody>
+      </p:sp>
+      <p:sp>
+        <p:nvSpPr>
+          <p:cNvPr id="26" name="obj195"/>
+          <p:cNvSpPr txBox="1"/>
+          <p:nvPr/>
+        </p:nvSpPr>
+        <p:spPr>
+          <a:xfrm>
+            <a:off x="685800" y="2724912"/>
+            <a:ext cx="1207008" cy="530352"/>
+          </a:xfrm>
+          <a:prstGeom prst="rect">
+            <a:avLst/>
+          </a:prstGeom>
+          <a:noFill/>
+          <a:ln/>
+        </p:spPr>
+        <p:txBody>
+          <a:bodyPr wrap="square" lIns="0" tIns="0" rIns="0" bIns="0" rtlCol="0" anchor="t"/>
+          <a:lstStyle/>
+          <a:p>
+            <a:pPr algn="l" indent="0" marL="0">
+              <a:buNone/>
+            </a:pPr>
+            <a:r>
+              <a:rPr lang="en-US" sz="1100" dirty="0">
+                <a:solidFill>
+                  <a:srgbClr val="1F2421"/>
+                </a:solidFill>
+                <a:latin typeface="Calibri" pitchFamily="34" charset="0"/>
+                <a:ea typeface="Calibri" pitchFamily="34" charset="-122"/>
+                <a:cs typeface="Calibri" pitchFamily="34" charset="-120"/>
+              </a:rPr>
+              <a:t>Agrupar frames en clips</a:t>
+            </a:r>
+            <a:endParaRPr lang="en-US" sz="1100" dirty="0"/>
+          </a:p>
+        </p:txBody>
+      </p:sp>
+      <p:sp>
+        <p:nvSpPr>
+          <p:cNvPr id="27" name="obj196"/>
+          <p:cNvSpPr/>
+          <p:nvPr/>
+        </p:nvSpPr>
+        <p:spPr>
+          <a:xfrm>
+            <a:off x="1920240" y="2624328"/>
             <a:ext cx="402336" cy="402336"/>
           </a:xfrm>
           <a:prstGeom prst="roundRect">
@@ -7958,13 +8312,13 @@
       </p:sp>
       <p:sp>
         <p:nvSpPr>
-          <p:cNvPr id="18" name="obj187"/>
-          <p:cNvSpPr txBox="1"/>
-          <p:nvPr/>
-        </p:nvSpPr>
-        <p:spPr>
-          <a:xfrm>
-            <a:off x="6035040" y="1600200"/>
+          <p:cNvPr id="28" name="obj197"/>
+          <p:cNvSpPr txBox="1"/>
+          <p:nvPr/>
+        </p:nvSpPr>
+        <p:spPr>
+          <a:xfrm>
+            <a:off x="1920240" y="2624328"/>
             <a:ext cx="402336" cy="402336"/>
           </a:xfrm>
           <a:prstGeom prst="rect">
@@ -7997,13 +8351,13 @@
       </p:sp>
       <p:sp>
         <p:nvSpPr>
-          <p:cNvPr id="19" name="obj188"/>
-          <p:cNvSpPr/>
-          <p:nvPr/>
-        </p:nvSpPr>
-        <p:spPr>
-          <a:xfrm>
-            <a:off x="6720840" y="1371600"/>
+          <p:cNvPr id="29" name="obj198"/>
+          <p:cNvSpPr/>
+          <p:nvPr/>
+        </p:nvSpPr>
+        <p:spPr>
+          <a:xfrm>
+            <a:off x="2606040" y="2395728"/>
             <a:ext cx="1874520" cy="914400"/>
           </a:xfrm>
           <a:prstGeom prst="roundRect">
@@ -8019,13 +8373,13 @@
       </p:sp>
       <p:sp>
         <p:nvSpPr>
-          <p:cNvPr id="20" name="obj189"/>
-          <p:cNvSpPr txBox="1"/>
-          <p:nvPr/>
-        </p:nvSpPr>
-        <p:spPr>
-          <a:xfrm>
-            <a:off x="6858000" y="1463040"/>
+          <p:cNvPr id="30" name="obj199"/>
+          <p:cNvSpPr txBox="1"/>
+          <p:nvPr/>
+        </p:nvSpPr>
+        <p:spPr>
+          <a:xfrm>
+            <a:off x="2743200" y="2487168"/>
             <a:ext cx="1188720" cy="228600"/>
           </a:xfrm>
           <a:prstGeom prst="rect">
@@ -8050,7 +8404,7 @@
                 <a:ea typeface="Calibri" pitchFamily="34" charset="-122"/>
                 <a:cs typeface="Calibri" pitchFamily="34" charset="-120"/>
               </a:rPr>
-              <a:t>HU04</a:t>
+              <a:t>HU06</a:t>
             </a:r>
             <a:pPr algn="l" indent="0" marL="0">
               <a:buNone/>
@@ -8064,7 +8418,7 @@
                 <a:ea typeface="Calibri" pitchFamily="34" charset="-122"/>
                 <a:cs typeface="Calibri" pitchFamily="34" charset="-120"/>
               </a:rPr>
-              <a:t> · EP02</a:t>
+              <a:t> · EP03</a:t>
             </a:r>
             <a:endParaRPr lang="en-US" sz="1100" dirty="0"/>
           </a:p>
@@ -8072,13 +8426,13 @@
       </p:sp>
       <p:sp>
         <p:nvSpPr>
-          <p:cNvPr id="21" name="obj190"/>
-          <p:cNvSpPr txBox="1"/>
-          <p:nvPr/>
-        </p:nvSpPr>
-        <p:spPr>
-          <a:xfrm>
-            <a:off x="6858000" y="1700784"/>
+          <p:cNvPr id="31" name="obj200"/>
+          <p:cNvSpPr txBox="1"/>
+          <p:nvPr/>
+        </p:nvSpPr>
+        <p:spPr>
+          <a:xfrm>
+            <a:off x="2743200" y="2724912"/>
             <a:ext cx="1207008" cy="530352"/>
           </a:xfrm>
           <a:prstGeom prst="rect">
@@ -8103,7 +8457,7 @@
                 <a:ea typeface="Calibri" pitchFamily="34" charset="-122"/>
                 <a:cs typeface="Calibri" pitchFamily="34" charset="-120"/>
               </a:rPr>
-              <a:t>Descartar frames sin trabajadores</a:t>
+              <a:t>Descartar clips muy cortos</a:t>
             </a:r>
             <a:endParaRPr lang="en-US" sz="1100" dirty="0"/>
           </a:p>
@@ -8111,13 +8465,13 @@
       </p:sp>
       <p:sp>
         <p:nvSpPr>
-          <p:cNvPr id="22" name="obj191"/>
-          <p:cNvSpPr/>
-          <p:nvPr/>
-        </p:nvSpPr>
-        <p:spPr>
-          <a:xfrm>
-            <a:off x="8092440" y="1600200"/>
+          <p:cNvPr id="32" name="obj201"/>
+          <p:cNvSpPr/>
+          <p:nvPr/>
+        </p:nvSpPr>
+        <p:spPr>
+          <a:xfrm>
+            <a:off x="3977640" y="2624328"/>
             <a:ext cx="402336" cy="402336"/>
           </a:xfrm>
           <a:prstGeom prst="roundRect">
@@ -8135,13 +8489,13 @@
       </p:sp>
       <p:sp>
         <p:nvSpPr>
-          <p:cNvPr id="23" name="obj192"/>
-          <p:cNvSpPr txBox="1"/>
-          <p:nvPr/>
-        </p:nvSpPr>
-        <p:spPr>
-          <a:xfrm>
-            <a:off x="8092440" y="1600200"/>
+          <p:cNvPr id="33" name="obj202"/>
+          <p:cNvSpPr txBox="1"/>
+          <p:nvPr/>
+        </p:nvSpPr>
+        <p:spPr>
+          <a:xfrm>
+            <a:off x="3977640" y="2624328"/>
             <a:ext cx="402336" cy="402336"/>
           </a:xfrm>
           <a:prstGeom prst="rect">
@@ -8174,13 +8528,13 @@
       </p:sp>
       <p:sp>
         <p:nvSpPr>
-          <p:cNvPr id="24" name="obj193"/>
-          <p:cNvSpPr/>
-          <p:nvPr/>
-        </p:nvSpPr>
-        <p:spPr>
-          <a:xfrm>
-            <a:off x="548640" y="2395728"/>
+          <p:cNvPr id="34" name="obj203"/>
+          <p:cNvSpPr/>
+          <p:nvPr/>
+        </p:nvSpPr>
+        <p:spPr>
+          <a:xfrm>
+            <a:off x="4663440" y="2395728"/>
             <a:ext cx="1874520" cy="914400"/>
           </a:xfrm>
           <a:prstGeom prst="roundRect">
@@ -8196,13 +8550,13 @@
       </p:sp>
       <p:sp>
         <p:nvSpPr>
-          <p:cNvPr id="25" name="obj194"/>
-          <p:cNvSpPr txBox="1"/>
-          <p:nvPr/>
-        </p:nvSpPr>
-        <p:spPr>
-          <a:xfrm>
-            <a:off x="685800" y="2487168"/>
+          <p:cNvPr id="35" name="obj204"/>
+          <p:cNvSpPr txBox="1"/>
+          <p:nvPr/>
+        </p:nvSpPr>
+        <p:spPr>
+          <a:xfrm>
+            <a:off x="4800600" y="2487168"/>
             <a:ext cx="1188720" cy="228600"/>
           </a:xfrm>
           <a:prstGeom prst="rect">
@@ -8227,7 +8581,7 @@
                 <a:ea typeface="Calibri" pitchFamily="34" charset="-122"/>
                 <a:cs typeface="Calibri" pitchFamily="34" charset="-120"/>
               </a:rPr>
-              <a:t>HU05</a:t>
+              <a:t>HU07</a:t>
             </a:r>
             <a:pPr algn="l" indent="0" marL="0">
               <a:buNone/>
@@ -8241,7 +8595,7 @@
                 <a:ea typeface="Calibri" pitchFamily="34" charset="-122"/>
                 <a:cs typeface="Calibri" pitchFamily="34" charset="-120"/>
               </a:rPr>
-              <a:t> · EP03</a:t>
+              <a:t> · EP04</a:t>
             </a:r>
             <a:endParaRPr lang="en-US" sz="1100" dirty="0"/>
           </a:p>
@@ -8249,13 +8603,13 @@
       </p:sp>
       <p:sp>
         <p:nvSpPr>
-          <p:cNvPr id="26" name="obj195"/>
-          <p:cNvSpPr txBox="1"/>
-          <p:nvPr/>
-        </p:nvSpPr>
-        <p:spPr>
-          <a:xfrm>
-            <a:off x="685800" y="2724912"/>
+          <p:cNvPr id="36" name="obj205"/>
+          <p:cNvSpPr txBox="1"/>
+          <p:nvPr/>
+        </p:nvSpPr>
+        <p:spPr>
+          <a:xfrm>
+            <a:off x="4800600" y="2724912"/>
             <a:ext cx="1207008" cy="530352"/>
           </a:xfrm>
           <a:prstGeom prst="rect">
@@ -8280,7 +8634,7 @@
                 <a:ea typeface="Calibri" pitchFamily="34" charset="-122"/>
                 <a:cs typeface="Calibri" pitchFamily="34" charset="-120"/>
               </a:rPr>
-              <a:t>Agrupar frames en clips</a:t>
+              <a:t>Procesar el clip con ConvLSTM</a:t>
             </a:r>
             <a:endParaRPr lang="en-US" sz="1100" dirty="0"/>
           </a:p>
@@ -8288,13 +8642,542 @@
       </p:sp>
       <p:sp>
         <p:nvSpPr>
-          <p:cNvPr id="27" name="obj196"/>
-          <p:cNvSpPr/>
-          <p:nvPr/>
-        </p:nvSpPr>
-        <p:spPr>
-          <a:xfrm>
-            <a:off x="1920240" y="2624328"/>
+          <p:cNvPr id="37" name="obj206"/>
+          <p:cNvSpPr/>
+          <p:nvPr/>
+        </p:nvSpPr>
+        <p:spPr>
+          <a:xfrm>
+            <a:off x="6035040" y="2624328"/>
+            <a:ext cx="402336" cy="402336"/>
+          </a:xfrm>
+          <a:prstGeom prst="roundRect">
+            <a:avLst>
+              <a:gd name="adj" fmla="val 50000"/>
+            </a:avLst>
+          </a:prstGeom>
+          <a:solidFill>
+            <a:srgbClr val="F2643D"/>
+          </a:solidFill>
+          <a:ln/>
+        </p:spPr>
+      </p:sp>
+      <p:sp>
+        <p:nvSpPr>
+          <p:cNvPr id="38" name="obj207"/>
+          <p:cNvSpPr txBox="1"/>
+          <p:nvPr/>
+        </p:nvSpPr>
+        <p:spPr>
+          <a:xfrm>
+            <a:off x="6035040" y="2624328"/>
+            <a:ext cx="402336" cy="402336"/>
+          </a:xfrm>
+          <a:prstGeom prst="rect">
+            <a:avLst/>
+          </a:prstGeom>
+          <a:noFill/>
+          <a:ln/>
+        </p:spPr>
+        <p:txBody>
+          <a:bodyPr wrap="square" lIns="0" tIns="0" rIns="0" bIns="0" rtlCol="0" anchor="ctr"/>
+          <a:lstStyle/>
+          <a:p>
+            <a:pPr algn="ctr" indent="0" marL="0">
+              <a:buNone/>
+            </a:pPr>
+            <a:r>
+              <a:rPr lang="en-US" sz="1600" b="1" dirty="0">
+                <a:solidFill>
+                  <a:srgbClr val="FFFFFF"/>
+                </a:solidFill>
+                <a:latin typeface="Calibri" pitchFamily="34" charset="0"/>
+                <a:ea typeface="Calibri" pitchFamily="34" charset="-122"/>
+                <a:cs typeface="Calibri" pitchFamily="34" charset="-120"/>
+              </a:rPr>
+              <a:t>5</a:t>
+            </a:r>
+            <a:endParaRPr lang="en-US" sz="1600" dirty="0"/>
+          </a:p>
+        </p:txBody>
+      </p:sp>
+      <p:sp>
+        <p:nvSpPr>
+          <p:cNvPr id="39" name="obj208"/>
+          <p:cNvSpPr/>
+          <p:nvPr/>
+        </p:nvSpPr>
+        <p:spPr>
+          <a:xfrm>
+            <a:off x="6720840" y="2395728"/>
+            <a:ext cx="1874520" cy="914400"/>
+          </a:xfrm>
+          <a:prstGeom prst="roundRect">
+            <a:avLst>
+              <a:gd name="adj" fmla="val 14000"/>
+            </a:avLst>
+          </a:prstGeom>
+          <a:solidFill>
+            <a:srgbClr val="F4F4F2"/>
+          </a:solidFill>
+          <a:ln/>
+        </p:spPr>
+      </p:sp>
+      <p:sp>
+        <p:nvSpPr>
+          <p:cNvPr id="40" name="obj209"/>
+          <p:cNvSpPr txBox="1"/>
+          <p:nvPr/>
+        </p:nvSpPr>
+        <p:spPr>
+          <a:xfrm>
+            <a:off x="6858000" y="2487168"/>
+            <a:ext cx="1188720" cy="228600"/>
+          </a:xfrm>
+          <a:prstGeom prst="rect">
+            <a:avLst/>
+          </a:prstGeom>
+          <a:noFill/>
+          <a:ln/>
+        </p:spPr>
+        <p:txBody>
+          <a:bodyPr wrap="square" lIns="0" tIns="0" rIns="0" bIns="0" rtlCol="0" anchor="t"/>
+          <a:lstStyle/>
+          <a:p>
+            <a:pPr algn="l" indent="0" marL="0">
+              <a:buNone/>
+            </a:pPr>
+            <a:r>
+              <a:rPr lang="en-US" sz="1100" b="1" dirty="0">
+                <a:solidFill>
+                  <a:srgbClr val="F2643D"/>
+                </a:solidFill>
+                <a:latin typeface="Calibri" pitchFamily="34" charset="0"/>
+                <a:ea typeface="Calibri" pitchFamily="34" charset="-122"/>
+                <a:cs typeface="Calibri" pitchFamily="34" charset="-120"/>
+              </a:rPr>
+              <a:t>HU08</a:t>
+            </a:r>
+            <a:pPr algn="l" indent="0" marL="0">
+              <a:buNone/>
+            </a:pPr>
+            <a:r>
+              <a:rPr lang="en-US" sz="1100" dirty="0">
+                <a:solidFill>
+                  <a:srgbClr val="F2643D"/>
+                </a:solidFill>
+                <a:latin typeface="Calibri" pitchFamily="34" charset="0"/>
+                <a:ea typeface="Calibri" pitchFamily="34" charset="-122"/>
+                <a:cs typeface="Calibri" pitchFamily="34" charset="-120"/>
+              </a:rPr>
+              <a:t> · EP04</a:t>
+            </a:r>
+            <a:endParaRPr lang="en-US" sz="1100" dirty="0"/>
+          </a:p>
+        </p:txBody>
+      </p:sp>
+      <p:sp>
+        <p:nvSpPr>
+          <p:cNvPr id="41" name="obj210"/>
+          <p:cNvSpPr txBox="1"/>
+          <p:nvPr/>
+        </p:nvSpPr>
+        <p:spPr>
+          <a:xfrm>
+            <a:off x="6858000" y="2724912"/>
+            <a:ext cx="1207008" cy="530352"/>
+          </a:xfrm>
+          <a:prstGeom prst="rect">
+            <a:avLst/>
+          </a:prstGeom>
+          <a:noFill/>
+          <a:ln/>
+        </p:spPr>
+        <p:txBody>
+          <a:bodyPr wrap="square" lIns="0" tIns="0" rIns="0" bIns="0" rtlCol="0" anchor="t"/>
+          <a:lstStyle/>
+          <a:p>
+            <a:pPr algn="l" indent="0" marL="0">
+              <a:buNone/>
+            </a:pPr>
+            <a:r>
+              <a:rPr lang="en-US" sz="1100" dirty="0">
+                <a:solidFill>
+                  <a:srgbClr val="1F2421"/>
+                </a:solidFill>
+                <a:latin typeface="Calibri" pitchFamily="34" charset="0"/>
+                <a:ea typeface="Calibri" pitchFamily="34" charset="-122"/>
+                <a:cs typeface="Calibri" pitchFamily="34" charset="-120"/>
+              </a:rPr>
+              <a:t>Clasificar y tipificar conducta</a:t>
+            </a:r>
+            <a:endParaRPr lang="en-US" sz="1100" dirty="0"/>
+          </a:p>
+        </p:txBody>
+      </p:sp>
+      <p:sp>
+        <p:nvSpPr>
+          <p:cNvPr id="42" name="obj211"/>
+          <p:cNvSpPr/>
+          <p:nvPr/>
+        </p:nvSpPr>
+        <p:spPr>
+          <a:xfrm>
+            <a:off x="8092440" y="2624328"/>
+            <a:ext cx="402336" cy="402336"/>
+          </a:xfrm>
+          <a:prstGeom prst="roundRect">
+            <a:avLst>
+              <a:gd name="adj" fmla="val 50000"/>
+            </a:avLst>
+          </a:prstGeom>
+          <a:solidFill>
+            <a:srgbClr val="F2643D">
+              <a:alpha val="65000"/>
+            </a:srgbClr>
+          </a:solidFill>
+          <a:ln/>
+        </p:spPr>
+      </p:sp>
+      <p:sp>
+        <p:nvSpPr>
+          <p:cNvPr id="43" name="obj212"/>
+          <p:cNvSpPr txBox="1"/>
+          <p:nvPr/>
+        </p:nvSpPr>
+        <p:spPr>
+          <a:xfrm>
+            <a:off x="8092440" y="2624328"/>
+            <a:ext cx="402336" cy="402336"/>
+          </a:xfrm>
+          <a:prstGeom prst="rect">
+            <a:avLst/>
+          </a:prstGeom>
+          <a:noFill/>
+          <a:ln/>
+        </p:spPr>
+        <p:txBody>
+          <a:bodyPr wrap="square" lIns="0" tIns="0" rIns="0" bIns="0" rtlCol="0" anchor="ctr"/>
+          <a:lstStyle/>
+          <a:p>
+            <a:pPr algn="ctr" indent="0" marL="0">
+              <a:buNone/>
+            </a:pPr>
+            <a:r>
+              <a:rPr lang="en-US" sz="1600" b="1" dirty="0">
+                <a:solidFill>
+                  <a:srgbClr val="FFFFFF"/>
+                </a:solidFill>
+                <a:latin typeface="Calibri" pitchFamily="34" charset="0"/>
+                <a:ea typeface="Calibri" pitchFamily="34" charset="-122"/>
+                <a:cs typeface="Calibri" pitchFamily="34" charset="-120"/>
+              </a:rPr>
+              <a:t>3</a:t>
+            </a:r>
+            <a:endParaRPr lang="en-US" sz="1600" dirty="0"/>
+          </a:p>
+        </p:txBody>
+      </p:sp>
+      <p:sp>
+        <p:nvSpPr>
+          <p:cNvPr id="44" name="obj213"/>
+          <p:cNvSpPr/>
+          <p:nvPr/>
+        </p:nvSpPr>
+        <p:spPr>
+          <a:xfrm>
+            <a:off x="548640" y="3419856"/>
+            <a:ext cx="1874520" cy="914400"/>
+          </a:xfrm>
+          <a:prstGeom prst="roundRect">
+            <a:avLst>
+              <a:gd name="adj" fmla="val 14000"/>
+            </a:avLst>
+          </a:prstGeom>
+          <a:solidFill>
+            <a:srgbClr val="F4F4F2"/>
+          </a:solidFill>
+          <a:ln/>
+        </p:spPr>
+      </p:sp>
+      <p:sp>
+        <p:nvSpPr>
+          <p:cNvPr id="45" name="obj214"/>
+          <p:cNvSpPr txBox="1"/>
+          <p:nvPr/>
+        </p:nvSpPr>
+        <p:spPr>
+          <a:xfrm>
+            <a:off x="685800" y="3511296"/>
+            <a:ext cx="1188720" cy="228600"/>
+          </a:xfrm>
+          <a:prstGeom prst="rect">
+            <a:avLst/>
+          </a:prstGeom>
+          <a:noFill/>
+          <a:ln/>
+        </p:spPr>
+        <p:txBody>
+          <a:bodyPr wrap="square" lIns="0" tIns="0" rIns="0" bIns="0" rtlCol="0" anchor="t"/>
+          <a:lstStyle/>
+          <a:p>
+            <a:pPr algn="l" indent="0" marL="0">
+              <a:buNone/>
+            </a:pPr>
+            <a:r>
+              <a:rPr lang="en-US" sz="1100" b="1" dirty="0">
+                <a:solidFill>
+                  <a:srgbClr val="F2643D"/>
+                </a:solidFill>
+                <a:latin typeface="Calibri" pitchFamily="34" charset="0"/>
+                <a:ea typeface="Calibri" pitchFamily="34" charset="-122"/>
+                <a:cs typeface="Calibri" pitchFamily="34" charset="-120"/>
+              </a:rPr>
+              <a:t>HU09</a:t>
+            </a:r>
+            <a:pPr algn="l" indent="0" marL="0">
+              <a:buNone/>
+            </a:pPr>
+            <a:r>
+              <a:rPr lang="en-US" sz="1100" dirty="0">
+                <a:solidFill>
+                  <a:srgbClr val="F2643D"/>
+                </a:solidFill>
+                <a:latin typeface="Calibri" pitchFamily="34" charset="0"/>
+                <a:ea typeface="Calibri" pitchFamily="34" charset="-122"/>
+                <a:cs typeface="Calibri" pitchFamily="34" charset="-120"/>
+              </a:rPr>
+              <a:t> · EP05</a:t>
+            </a:r>
+            <a:endParaRPr lang="en-US" sz="1100" dirty="0"/>
+          </a:p>
+        </p:txBody>
+      </p:sp>
+      <p:sp>
+        <p:nvSpPr>
+          <p:cNvPr id="46" name="obj215"/>
+          <p:cNvSpPr txBox="1"/>
+          <p:nvPr/>
+        </p:nvSpPr>
+        <p:spPr>
+          <a:xfrm>
+            <a:off x="685800" y="3749040"/>
+            <a:ext cx="1207008" cy="530352"/>
+          </a:xfrm>
+          <a:prstGeom prst="rect">
+            <a:avLst/>
+          </a:prstGeom>
+          <a:noFill/>
+          <a:ln/>
+        </p:spPr>
+        <p:txBody>
+          <a:bodyPr wrap="square" lIns="0" tIns="0" rIns="0" bIns="0" rtlCol="0" anchor="t"/>
+          <a:lstStyle/>
+          <a:p>
+            <a:pPr algn="l" indent="0" marL="0">
+              <a:buNone/>
+            </a:pPr>
+            <a:r>
+              <a:rPr lang="en-US" sz="1100" dirty="0">
+                <a:solidFill>
+                  <a:srgbClr val="1F2421"/>
+                </a:solidFill>
+                <a:latin typeface="Calibri" pitchFamily="34" charset="0"/>
+                <a:ea typeface="Calibri" pitchFamily="34" charset="-122"/>
+                <a:cs typeface="Calibri" pitchFamily="34" charset="-120"/>
+              </a:rPr>
+              <a:t>Ver el video con recuadro</a:t>
+            </a:r>
+            <a:endParaRPr lang="en-US" sz="1100" dirty="0"/>
+          </a:p>
+        </p:txBody>
+      </p:sp>
+      <p:sp>
+        <p:nvSpPr>
+          <p:cNvPr id="47" name="obj216"/>
+          <p:cNvSpPr/>
+          <p:nvPr/>
+        </p:nvSpPr>
+        <p:spPr>
+          <a:xfrm>
+            <a:off x="1920240" y="3648456"/>
+            <a:ext cx="402336" cy="402336"/>
+          </a:xfrm>
+          <a:prstGeom prst="roundRect">
+            <a:avLst>
+              <a:gd name="adj" fmla="val 50000"/>
+            </a:avLst>
+          </a:prstGeom>
+          <a:solidFill>
+            <a:srgbClr val="F2643D">
+              <a:alpha val="85000"/>
+            </a:srgbClr>
+          </a:solidFill>
+          <a:ln/>
+        </p:spPr>
+      </p:sp>
+      <p:sp>
+        <p:nvSpPr>
+          <p:cNvPr id="48" name="obj217"/>
+          <p:cNvSpPr txBox="1"/>
+          <p:nvPr/>
+        </p:nvSpPr>
+        <p:spPr>
+          <a:xfrm>
+            <a:off x="1920240" y="3648456"/>
+            <a:ext cx="402336" cy="402336"/>
+          </a:xfrm>
+          <a:prstGeom prst="rect">
+            <a:avLst/>
+          </a:prstGeom>
+          <a:noFill/>
+          <a:ln/>
+        </p:spPr>
+        <p:txBody>
+          <a:bodyPr wrap="square" lIns="0" tIns="0" rIns="0" bIns="0" rtlCol="0" anchor="ctr"/>
+          <a:lstStyle/>
+          <a:p>
+            <a:pPr algn="ctr" indent="0" marL="0">
+              <a:buNone/>
+            </a:pPr>
+            <a:r>
+              <a:rPr lang="en-US" sz="1600" b="1" dirty="0">
+                <a:solidFill>
+                  <a:srgbClr val="FFFFFF"/>
+                </a:solidFill>
+                <a:latin typeface="Calibri" pitchFamily="34" charset="0"/>
+                <a:ea typeface="Calibri" pitchFamily="34" charset="-122"/>
+                <a:cs typeface="Calibri" pitchFamily="34" charset="-120"/>
+              </a:rPr>
+              <a:t>4</a:t>
+            </a:r>
+            <a:endParaRPr lang="en-US" sz="1600" dirty="0"/>
+          </a:p>
+        </p:txBody>
+      </p:sp>
+      <p:sp>
+        <p:nvSpPr>
+          <p:cNvPr id="49" name="obj218"/>
+          <p:cNvSpPr/>
+          <p:nvPr/>
+        </p:nvSpPr>
+        <p:spPr>
+          <a:xfrm>
+            <a:off x="2606040" y="3419856"/>
+            <a:ext cx="1874520" cy="914400"/>
+          </a:xfrm>
+          <a:prstGeom prst="roundRect">
+            <a:avLst>
+              <a:gd name="adj" fmla="val 14000"/>
+            </a:avLst>
+          </a:prstGeom>
+          <a:solidFill>
+            <a:srgbClr val="F4F4F2"/>
+          </a:solidFill>
+          <a:ln/>
+        </p:spPr>
+      </p:sp>
+      <p:sp>
+        <p:nvSpPr>
+          <p:cNvPr id="50" name="obj219"/>
+          <p:cNvSpPr txBox="1"/>
+          <p:nvPr/>
+        </p:nvSpPr>
+        <p:spPr>
+          <a:xfrm>
+            <a:off x="2743200" y="3511296"/>
+            <a:ext cx="1188720" cy="228600"/>
+          </a:xfrm>
+          <a:prstGeom prst="rect">
+            <a:avLst/>
+          </a:prstGeom>
+          <a:noFill/>
+          <a:ln/>
+        </p:spPr>
+        <p:txBody>
+          <a:bodyPr wrap="square" lIns="0" tIns="0" rIns="0" bIns="0" rtlCol="0" anchor="t"/>
+          <a:lstStyle/>
+          <a:p>
+            <a:pPr algn="l" indent="0" marL="0">
+              <a:buNone/>
+            </a:pPr>
+            <a:r>
+              <a:rPr lang="en-US" sz="1100" b="1" dirty="0">
+                <a:solidFill>
+                  <a:srgbClr val="F2643D"/>
+                </a:solidFill>
+                <a:latin typeface="Calibri" pitchFamily="34" charset="0"/>
+                <a:ea typeface="Calibri" pitchFamily="34" charset="-122"/>
+                <a:cs typeface="Calibri" pitchFamily="34" charset="-120"/>
+              </a:rPr>
+              <a:t>HU10</a:t>
+            </a:r>
+            <a:pPr algn="l" indent="0" marL="0">
+              <a:buNone/>
+            </a:pPr>
+            <a:r>
+              <a:rPr lang="en-US" sz="1100" dirty="0">
+                <a:solidFill>
+                  <a:srgbClr val="F2643D"/>
+                </a:solidFill>
+                <a:latin typeface="Calibri" pitchFamily="34" charset="0"/>
+                <a:ea typeface="Calibri" pitchFamily="34" charset="-122"/>
+                <a:cs typeface="Calibri" pitchFamily="34" charset="-120"/>
+              </a:rPr>
+              <a:t> · EP05</a:t>
+            </a:r>
+            <a:endParaRPr lang="en-US" sz="1100" dirty="0"/>
+          </a:p>
+        </p:txBody>
+      </p:sp>
+      <p:sp>
+        <p:nvSpPr>
+          <p:cNvPr id="51" name="obj220"/>
+          <p:cNvSpPr txBox="1"/>
+          <p:nvPr/>
+        </p:nvSpPr>
+        <p:spPr>
+          <a:xfrm>
+            <a:off x="2743200" y="3749040"/>
+            <a:ext cx="1207008" cy="530352"/>
+          </a:xfrm>
+          <a:prstGeom prst="rect">
+            <a:avLst/>
+          </a:prstGeom>
+          <a:noFill/>
+          <a:ln/>
+        </p:spPr>
+        <p:txBody>
+          <a:bodyPr wrap="square" lIns="0" tIns="0" rIns="0" bIns="0" rtlCol="0" anchor="t"/>
+          <a:lstStyle/>
+          <a:p>
+            <a:pPr algn="l" indent="0" marL="0">
+              <a:buNone/>
+            </a:pPr>
+            <a:r>
+              <a:rPr lang="en-US" sz="1100" dirty="0">
+                <a:solidFill>
+                  <a:srgbClr val="1F2421"/>
+                </a:solidFill>
+                <a:latin typeface="Calibri" pitchFamily="34" charset="0"/>
+                <a:ea typeface="Calibri" pitchFamily="34" charset="-122"/>
+                <a:cs typeface="Calibri" pitchFamily="34" charset="-120"/>
+              </a:rPr>
+              <a:t>Activar alerta de riesgo</a:t>
+            </a:r>
+            <a:endParaRPr lang="en-US" sz="1100" dirty="0"/>
+          </a:p>
+        </p:txBody>
+      </p:sp>
+      <p:sp>
+        <p:nvSpPr>
+          <p:cNvPr id="52" name="obj221"/>
+          <p:cNvSpPr/>
+          <p:nvPr/>
+        </p:nvSpPr>
+        <p:spPr>
+          <a:xfrm>
+            <a:off x="3977640" y="3648456"/>
             <a:ext cx="402336" cy="402336"/>
           </a:xfrm>
           <a:prstGeom prst="roundRect">
@@ -8312,13 +9195,13 @@
       </p:sp>
       <p:sp>
         <p:nvSpPr>
-          <p:cNvPr id="28" name="obj197"/>
-          <p:cNvSpPr txBox="1"/>
-          <p:nvPr/>
-        </p:nvSpPr>
-        <p:spPr>
-          <a:xfrm>
-            <a:off x="1920240" y="2624328"/>
+          <p:cNvPr id="53" name="obj222"/>
+          <p:cNvSpPr txBox="1"/>
+          <p:nvPr/>
+        </p:nvSpPr>
+        <p:spPr>
+          <a:xfrm>
+            <a:off x="3977640" y="3648456"/>
             <a:ext cx="402336" cy="402336"/>
           </a:xfrm>
           <a:prstGeom prst="rect">
@@ -8351,13 +9234,13 @@
       </p:sp>
       <p:sp>
         <p:nvSpPr>
-          <p:cNvPr id="29" name="obj198"/>
-          <p:cNvSpPr/>
-          <p:nvPr/>
-        </p:nvSpPr>
-        <p:spPr>
-          <a:xfrm>
-            <a:off x="2606040" y="2395728"/>
+          <p:cNvPr id="54" name="obj223"/>
+          <p:cNvSpPr/>
+          <p:nvPr/>
+        </p:nvSpPr>
+        <p:spPr>
+          <a:xfrm>
+            <a:off x="4663440" y="3419856"/>
             <a:ext cx="1874520" cy="914400"/>
           </a:xfrm>
           <a:prstGeom prst="roundRect">
@@ -8373,13 +9256,13 @@
       </p:sp>
       <p:sp>
         <p:nvSpPr>
-          <p:cNvPr id="30" name="obj199"/>
-          <p:cNvSpPr txBox="1"/>
-          <p:nvPr/>
-        </p:nvSpPr>
-        <p:spPr>
-          <a:xfrm>
-            <a:off x="2743200" y="2487168"/>
+          <p:cNvPr id="55" name="obj224"/>
+          <p:cNvSpPr txBox="1"/>
+          <p:nvPr/>
+        </p:nvSpPr>
+        <p:spPr>
+          <a:xfrm>
+            <a:off x="4800600" y="3511296"/>
             <a:ext cx="1188720" cy="228600"/>
           </a:xfrm>
           <a:prstGeom prst="rect">
@@ -8404,7 +9287,7 @@
                 <a:ea typeface="Calibri" pitchFamily="34" charset="-122"/>
                 <a:cs typeface="Calibri" pitchFamily="34" charset="-120"/>
               </a:rPr>
-              <a:t>HU06</a:t>
+              <a:t>HU11</a:t>
             </a:r>
             <a:pPr algn="l" indent="0" marL="0">
               <a:buNone/>
@@ -8418,7 +9301,7 @@
                 <a:ea typeface="Calibri" pitchFamily="34" charset="-122"/>
                 <a:cs typeface="Calibri" pitchFamily="34" charset="-120"/>
               </a:rPr>
-              <a:t> · EP03</a:t>
+              <a:t> · EP06</a:t>
             </a:r>
             <a:endParaRPr lang="en-US" sz="1100" dirty="0"/>
           </a:p>
@@ -8426,13 +9309,13 @@
       </p:sp>
       <p:sp>
         <p:nvSpPr>
-          <p:cNvPr id="31" name="obj200"/>
-          <p:cNvSpPr txBox="1"/>
-          <p:nvPr/>
-        </p:nvSpPr>
-        <p:spPr>
-          <a:xfrm>
-            <a:off x="2743200" y="2724912"/>
+          <p:cNvPr id="56" name="obj225"/>
+          <p:cNvSpPr txBox="1"/>
+          <p:nvPr/>
+        </p:nvSpPr>
+        <p:spPr>
+          <a:xfrm>
+            <a:off x="4800600" y="3749040"/>
             <a:ext cx="1207008" cy="530352"/>
           </a:xfrm>
           <a:prstGeom prst="rect">
@@ -8457,7 +9340,7 @@
                 <a:ea typeface="Calibri" pitchFamily="34" charset="-122"/>
                 <a:cs typeface="Calibri" pitchFamily="34" charset="-120"/>
               </a:rPr>
-              <a:t>Descartar clips muy cortos</a:t>
+              <a:t>Ajustar umbral de YOLOv8</a:t>
             </a:r>
             <a:endParaRPr lang="en-US" sz="1100" dirty="0"/>
           </a:p>
@@ -8465,13 +9348,190 @@
       </p:sp>
       <p:sp>
         <p:nvSpPr>
-          <p:cNvPr id="32" name="obj201"/>
-          <p:cNvSpPr/>
-          <p:nvPr/>
-        </p:nvSpPr>
-        <p:spPr>
-          <a:xfrm>
-            <a:off x="3977640" y="2624328"/>
+          <p:cNvPr id="57" name="obj226"/>
+          <p:cNvSpPr/>
+          <p:nvPr/>
+        </p:nvSpPr>
+        <p:spPr>
+          <a:xfrm>
+            <a:off x="6035040" y="3648456"/>
+            <a:ext cx="402336" cy="402336"/>
+          </a:xfrm>
+          <a:prstGeom prst="roundRect">
+            <a:avLst>
+              <a:gd name="adj" fmla="val 50000"/>
+            </a:avLst>
+          </a:prstGeom>
+          <a:solidFill>
+            <a:srgbClr val="F2643D">
+              <a:alpha val="28000"/>
+            </a:srgbClr>
+          </a:solidFill>
+          <a:ln/>
+        </p:spPr>
+      </p:sp>
+      <p:sp>
+        <p:nvSpPr>
+          <p:cNvPr id="58" name="obj227"/>
+          <p:cNvSpPr txBox="1"/>
+          <p:nvPr/>
+        </p:nvSpPr>
+        <p:spPr>
+          <a:xfrm>
+            <a:off x="6035040" y="3648456"/>
+            <a:ext cx="402336" cy="402336"/>
+          </a:xfrm>
+          <a:prstGeom prst="rect">
+            <a:avLst/>
+          </a:prstGeom>
+          <a:noFill/>
+          <a:ln/>
+        </p:spPr>
+        <p:txBody>
+          <a:bodyPr wrap="square" lIns="0" tIns="0" rIns="0" bIns="0" rtlCol="0" anchor="ctr"/>
+          <a:lstStyle/>
+          <a:p>
+            <a:pPr algn="ctr" indent="0" marL="0">
+              <a:buNone/>
+            </a:pPr>
+            <a:r>
+              <a:rPr lang="en-US" sz="1600" b="1" dirty="0">
+                <a:solidFill>
+                  <a:srgbClr val="1F2421"/>
+                </a:solidFill>
+                <a:latin typeface="Calibri" pitchFamily="34" charset="0"/>
+                <a:ea typeface="Calibri" pitchFamily="34" charset="-122"/>
+                <a:cs typeface="Calibri" pitchFamily="34" charset="-120"/>
+              </a:rPr>
+              <a:t>1</a:t>
+            </a:r>
+            <a:endParaRPr lang="en-US" sz="1600" dirty="0"/>
+          </a:p>
+        </p:txBody>
+      </p:sp>
+      <p:sp>
+        <p:nvSpPr>
+          <p:cNvPr id="59" name="obj228"/>
+          <p:cNvSpPr/>
+          <p:nvPr/>
+        </p:nvSpPr>
+        <p:spPr>
+          <a:xfrm>
+            <a:off x="6720840" y="3419856"/>
+            <a:ext cx="1874520" cy="914400"/>
+          </a:xfrm>
+          <a:prstGeom prst="roundRect">
+            <a:avLst>
+              <a:gd name="adj" fmla="val 14000"/>
+            </a:avLst>
+          </a:prstGeom>
+          <a:solidFill>
+            <a:srgbClr val="F4F4F2"/>
+          </a:solidFill>
+          <a:ln/>
+        </p:spPr>
+      </p:sp>
+      <p:sp>
+        <p:nvSpPr>
+          <p:cNvPr id="60" name="obj229"/>
+          <p:cNvSpPr txBox="1"/>
+          <p:nvPr/>
+        </p:nvSpPr>
+        <p:spPr>
+          <a:xfrm>
+            <a:off x="6858000" y="3511296"/>
+            <a:ext cx="1188720" cy="228600"/>
+          </a:xfrm>
+          <a:prstGeom prst="rect">
+            <a:avLst/>
+          </a:prstGeom>
+          <a:noFill/>
+          <a:ln/>
+        </p:spPr>
+        <p:txBody>
+          <a:bodyPr wrap="square" lIns="0" tIns="0" rIns="0" bIns="0" rtlCol="0" anchor="t"/>
+          <a:lstStyle/>
+          <a:p>
+            <a:pPr algn="l" indent="0" marL="0">
+              <a:buNone/>
+            </a:pPr>
+            <a:r>
+              <a:rPr lang="en-US" sz="1100" b="1" dirty="0">
+                <a:solidFill>
+                  <a:srgbClr val="F2643D"/>
+                </a:solidFill>
+                <a:latin typeface="Calibri" pitchFamily="34" charset="0"/>
+                <a:ea typeface="Calibri" pitchFamily="34" charset="-122"/>
+                <a:cs typeface="Calibri" pitchFamily="34" charset="-120"/>
+              </a:rPr>
+              <a:t>HU12</a:t>
+            </a:r>
+            <a:pPr algn="l" indent="0" marL="0">
+              <a:buNone/>
+            </a:pPr>
+            <a:r>
+              <a:rPr lang="en-US" sz="1100" dirty="0">
+                <a:solidFill>
+                  <a:srgbClr val="F2643D"/>
+                </a:solidFill>
+                <a:latin typeface="Calibri" pitchFamily="34" charset="0"/>
+                <a:ea typeface="Calibri" pitchFamily="34" charset="-122"/>
+                <a:cs typeface="Calibri" pitchFamily="34" charset="-120"/>
+              </a:rPr>
+              <a:t> · EP06</a:t>
+            </a:r>
+            <a:endParaRPr lang="en-US" sz="1100" dirty="0"/>
+          </a:p>
+        </p:txBody>
+      </p:sp>
+      <p:sp>
+        <p:nvSpPr>
+          <p:cNvPr id="61" name="obj230"/>
+          <p:cNvSpPr txBox="1"/>
+          <p:nvPr/>
+        </p:nvSpPr>
+        <p:spPr>
+          <a:xfrm>
+            <a:off x="6858000" y="3749040"/>
+            <a:ext cx="1207008" cy="530352"/>
+          </a:xfrm>
+          <a:prstGeom prst="rect">
+            <a:avLst/>
+          </a:prstGeom>
+          <a:noFill/>
+          <a:ln/>
+        </p:spPr>
+        <p:txBody>
+          <a:bodyPr wrap="square" lIns="0" tIns="0" rIns="0" bIns="0" rtlCol="0" anchor="t"/>
+          <a:lstStyle/>
+          <a:p>
+            <a:pPr algn="l" indent="0" marL="0">
+              <a:buNone/>
+            </a:pPr>
+            <a:r>
+              <a:rPr lang="en-US" sz="1100" dirty="0">
+                <a:solidFill>
+                  <a:srgbClr val="1F2421"/>
+                </a:solidFill>
+                <a:latin typeface="Calibri" pitchFamily="34" charset="0"/>
+                <a:ea typeface="Calibri" pitchFamily="34" charset="-122"/>
+                <a:cs typeface="Calibri" pitchFamily="34" charset="-120"/>
+              </a:rPr>
+              <a:t>Ver log de tiempos y ahorro</a:t>
+            </a:r>
+            <a:endParaRPr lang="en-US" sz="1100" dirty="0"/>
+          </a:p>
+        </p:txBody>
+      </p:sp>
+      <p:sp>
+        <p:nvSpPr>
+          <p:cNvPr id="62" name="obj231"/>
+          <p:cNvSpPr/>
+          <p:nvPr/>
+        </p:nvSpPr>
+        <p:spPr>
+          <a:xfrm>
+            <a:off x="8092440" y="3648456"/>
             <a:ext cx="402336" cy="402336"/>
           </a:xfrm>
           <a:prstGeom prst="roundRect">
@@ -8489,1046 +9549,8 @@
       </p:sp>
       <p:sp>
         <p:nvSpPr>
-          <p:cNvPr id="33" name="obj202"/>
-          <p:cNvSpPr txBox="1"/>
-          <p:nvPr/>
-        </p:nvSpPr>
-        <p:spPr>
-          <a:xfrm>
-            <a:off x="3977640" y="2624328"/>
-            <a:ext cx="402336" cy="402336"/>
-          </a:xfrm>
-          <a:prstGeom prst="rect">
-            <a:avLst/>
-          </a:prstGeom>
-          <a:noFill/>
-          <a:ln/>
-        </p:spPr>
-        <p:txBody>
-          <a:bodyPr wrap="square" lIns="0" tIns="0" rIns="0" bIns="0" rtlCol="0" anchor="ctr"/>
-          <a:lstStyle/>
-          <a:p>
-            <a:pPr algn="ctr" indent="0" marL="0">
-              <a:buNone/>
-            </a:pPr>
-            <a:r>
-              <a:rPr lang="en-US" sz="1600" b="1" dirty="0">
-                <a:solidFill>
-                  <a:srgbClr val="1F2421"/>
-                </a:solidFill>
-                <a:latin typeface="Calibri" pitchFamily="34" charset="0"/>
-                <a:ea typeface="Calibri" pitchFamily="34" charset="-122"/>
-                <a:cs typeface="Calibri" pitchFamily="34" charset="-120"/>
-              </a:rPr>
-              <a:t>2</a:t>
-            </a:r>
-            <a:endParaRPr lang="en-US" sz="1600" dirty="0"/>
-          </a:p>
-        </p:txBody>
-      </p:sp>
-      <p:sp>
-        <p:nvSpPr>
-          <p:cNvPr id="34" name="obj203"/>
-          <p:cNvSpPr/>
-          <p:nvPr/>
-        </p:nvSpPr>
-        <p:spPr>
-          <a:xfrm>
-            <a:off x="4663440" y="2395728"/>
-            <a:ext cx="1874520" cy="914400"/>
-          </a:xfrm>
-          <a:prstGeom prst="roundRect">
-            <a:avLst>
-              <a:gd name="adj" fmla="val 14000"/>
-            </a:avLst>
-          </a:prstGeom>
-          <a:solidFill>
-            <a:srgbClr val="F4F4F2"/>
-          </a:solidFill>
-          <a:ln/>
-        </p:spPr>
-      </p:sp>
-      <p:sp>
-        <p:nvSpPr>
-          <p:cNvPr id="35" name="obj204"/>
-          <p:cNvSpPr txBox="1"/>
-          <p:nvPr/>
-        </p:nvSpPr>
-        <p:spPr>
-          <a:xfrm>
-            <a:off x="4800600" y="2487168"/>
-            <a:ext cx="1188720" cy="228600"/>
-          </a:xfrm>
-          <a:prstGeom prst="rect">
-            <a:avLst/>
-          </a:prstGeom>
-          <a:noFill/>
-          <a:ln/>
-        </p:spPr>
-        <p:txBody>
-          <a:bodyPr wrap="square" lIns="0" tIns="0" rIns="0" bIns="0" rtlCol="0" anchor="t"/>
-          <a:lstStyle/>
-          <a:p>
-            <a:pPr algn="l" indent="0" marL="0">
-              <a:buNone/>
-            </a:pPr>
-            <a:r>
-              <a:rPr lang="en-US" sz="1100" b="1" dirty="0">
-                <a:solidFill>
-                  <a:srgbClr val="F2643D"/>
-                </a:solidFill>
-                <a:latin typeface="Calibri" pitchFamily="34" charset="0"/>
-                <a:ea typeface="Calibri" pitchFamily="34" charset="-122"/>
-                <a:cs typeface="Calibri" pitchFamily="34" charset="-120"/>
-              </a:rPr>
-              <a:t>HU07</a:t>
-            </a:r>
-            <a:pPr algn="l" indent="0" marL="0">
-              <a:buNone/>
-            </a:pPr>
-            <a:r>
-              <a:rPr lang="en-US" sz="1100" dirty="0">
-                <a:solidFill>
-                  <a:srgbClr val="F2643D"/>
-                </a:solidFill>
-                <a:latin typeface="Calibri" pitchFamily="34" charset="0"/>
-                <a:ea typeface="Calibri" pitchFamily="34" charset="-122"/>
-                <a:cs typeface="Calibri" pitchFamily="34" charset="-120"/>
-              </a:rPr>
-              <a:t> · EP04</a:t>
-            </a:r>
-            <a:endParaRPr lang="en-US" sz="1100" dirty="0"/>
-          </a:p>
-        </p:txBody>
-      </p:sp>
-      <p:sp>
-        <p:nvSpPr>
-          <p:cNvPr id="36" name="obj205"/>
-          <p:cNvSpPr txBox="1"/>
-          <p:nvPr/>
-        </p:nvSpPr>
-        <p:spPr>
-          <a:xfrm>
-            <a:off x="4800600" y="2724912"/>
-            <a:ext cx="1207008" cy="530352"/>
-          </a:xfrm>
-          <a:prstGeom prst="rect">
-            <a:avLst/>
-          </a:prstGeom>
-          <a:noFill/>
-          <a:ln/>
-        </p:spPr>
-        <p:txBody>
-          <a:bodyPr wrap="square" lIns="0" tIns="0" rIns="0" bIns="0" rtlCol="0" anchor="t"/>
-          <a:lstStyle/>
-          <a:p>
-            <a:pPr algn="l" indent="0" marL="0">
-              <a:buNone/>
-            </a:pPr>
-            <a:r>
-              <a:rPr lang="en-US" sz="1100" dirty="0">
-                <a:solidFill>
-                  <a:srgbClr val="1F2421"/>
-                </a:solidFill>
-                <a:latin typeface="Calibri" pitchFamily="34" charset="0"/>
-                <a:ea typeface="Calibri" pitchFamily="34" charset="-122"/>
-                <a:cs typeface="Calibri" pitchFamily="34" charset="-120"/>
-              </a:rPr>
-              <a:t>Procesar el clip con ConvLSTM</a:t>
-            </a:r>
-            <a:endParaRPr lang="en-US" sz="1100" dirty="0"/>
-          </a:p>
-        </p:txBody>
-      </p:sp>
-      <p:sp>
-        <p:nvSpPr>
-          <p:cNvPr id="37" name="obj206"/>
-          <p:cNvSpPr/>
-          <p:nvPr/>
-        </p:nvSpPr>
-        <p:spPr>
-          <a:xfrm>
-            <a:off x="6035040" y="2624328"/>
-            <a:ext cx="402336" cy="402336"/>
-          </a:xfrm>
-          <a:prstGeom prst="roundRect">
-            <a:avLst>
-              <a:gd name="adj" fmla="val 50000"/>
-            </a:avLst>
-          </a:prstGeom>
-          <a:solidFill>
-            <a:srgbClr val="F2643D">
-              <a:alpha val="85000"/>
-            </a:srgbClr>
-          </a:solidFill>
-          <a:ln/>
-        </p:spPr>
-      </p:sp>
-      <p:sp>
-        <p:nvSpPr>
-          <p:cNvPr id="38" name="obj207"/>
-          <p:cNvSpPr txBox="1"/>
-          <p:nvPr/>
-        </p:nvSpPr>
-        <p:spPr>
-          <a:xfrm>
-            <a:off x="6035040" y="2624328"/>
-            <a:ext cx="402336" cy="402336"/>
-          </a:xfrm>
-          <a:prstGeom prst="rect">
-            <a:avLst/>
-          </a:prstGeom>
-          <a:noFill/>
-          <a:ln/>
-        </p:spPr>
-        <p:txBody>
-          <a:bodyPr wrap="square" lIns="0" tIns="0" rIns="0" bIns="0" rtlCol="0" anchor="ctr"/>
-          <a:lstStyle/>
-          <a:p>
-            <a:pPr algn="ctr" indent="0" marL="0">
-              <a:buNone/>
-            </a:pPr>
-            <a:r>
-              <a:rPr lang="en-US" sz="1600" b="1" dirty="0">
-                <a:solidFill>
-                  <a:srgbClr val="FFFFFF"/>
-                </a:solidFill>
-                <a:latin typeface="Calibri" pitchFamily="34" charset="0"/>
-                <a:ea typeface="Calibri" pitchFamily="34" charset="-122"/>
-                <a:cs typeface="Calibri" pitchFamily="34" charset="-120"/>
-              </a:rPr>
-              <a:t>4</a:t>
-            </a:r>
-            <a:endParaRPr lang="en-US" sz="1600" dirty="0"/>
-          </a:p>
-        </p:txBody>
-      </p:sp>
-      <p:sp>
-        <p:nvSpPr>
-          <p:cNvPr id="39" name="obj208"/>
-          <p:cNvSpPr/>
-          <p:nvPr/>
-        </p:nvSpPr>
-        <p:spPr>
-          <a:xfrm>
-            <a:off x="6720840" y="2395728"/>
-            <a:ext cx="1874520" cy="914400"/>
-          </a:xfrm>
-          <a:prstGeom prst="roundRect">
-            <a:avLst>
-              <a:gd name="adj" fmla="val 14000"/>
-            </a:avLst>
-          </a:prstGeom>
-          <a:solidFill>
-            <a:srgbClr val="F4F4F2"/>
-          </a:solidFill>
-          <a:ln/>
-        </p:spPr>
-      </p:sp>
-      <p:sp>
-        <p:nvSpPr>
-          <p:cNvPr id="40" name="obj209"/>
-          <p:cNvSpPr txBox="1"/>
-          <p:nvPr/>
-        </p:nvSpPr>
-        <p:spPr>
-          <a:xfrm>
-            <a:off x="6858000" y="2487168"/>
-            <a:ext cx="1188720" cy="228600"/>
-          </a:xfrm>
-          <a:prstGeom prst="rect">
-            <a:avLst/>
-          </a:prstGeom>
-          <a:noFill/>
-          <a:ln/>
-        </p:spPr>
-        <p:txBody>
-          <a:bodyPr wrap="square" lIns="0" tIns="0" rIns="0" bIns="0" rtlCol="0" anchor="t"/>
-          <a:lstStyle/>
-          <a:p>
-            <a:pPr algn="l" indent="0" marL="0">
-              <a:buNone/>
-            </a:pPr>
-            <a:r>
-              <a:rPr lang="en-US" sz="1100" b="1" dirty="0">
-                <a:solidFill>
-                  <a:srgbClr val="F2643D"/>
-                </a:solidFill>
-                <a:latin typeface="Calibri" pitchFamily="34" charset="0"/>
-                <a:ea typeface="Calibri" pitchFamily="34" charset="-122"/>
-                <a:cs typeface="Calibri" pitchFamily="34" charset="-120"/>
-              </a:rPr>
-              <a:t>HU08</a:t>
-            </a:r>
-            <a:pPr algn="l" indent="0" marL="0">
-              <a:buNone/>
-            </a:pPr>
-            <a:r>
-              <a:rPr lang="en-US" sz="1100" dirty="0">
-                <a:solidFill>
-                  <a:srgbClr val="F2643D"/>
-                </a:solidFill>
-                <a:latin typeface="Calibri" pitchFamily="34" charset="0"/>
-                <a:ea typeface="Calibri" pitchFamily="34" charset="-122"/>
-                <a:cs typeface="Calibri" pitchFamily="34" charset="-120"/>
-              </a:rPr>
-              <a:t> · EP04</a:t>
-            </a:r>
-            <a:endParaRPr lang="en-US" sz="1100" dirty="0"/>
-          </a:p>
-        </p:txBody>
-      </p:sp>
-      <p:sp>
-        <p:nvSpPr>
-          <p:cNvPr id="41" name="obj210"/>
-          <p:cNvSpPr txBox="1"/>
-          <p:nvPr/>
-        </p:nvSpPr>
-        <p:spPr>
-          <a:xfrm>
-            <a:off x="6858000" y="2724912"/>
-            <a:ext cx="1207008" cy="530352"/>
-          </a:xfrm>
-          <a:prstGeom prst="rect">
-            <a:avLst/>
-          </a:prstGeom>
-          <a:noFill/>
-          <a:ln/>
-        </p:spPr>
-        <p:txBody>
-          <a:bodyPr wrap="square" lIns="0" tIns="0" rIns="0" bIns="0" rtlCol="0" anchor="t"/>
-          <a:lstStyle/>
-          <a:p>
-            <a:pPr algn="l" indent="0" marL="0">
-              <a:buNone/>
-            </a:pPr>
-            <a:r>
-              <a:rPr lang="en-US" sz="1100" dirty="0">
-                <a:solidFill>
-                  <a:srgbClr val="1F2421"/>
-                </a:solidFill>
-                <a:latin typeface="Calibri" pitchFamily="34" charset="0"/>
-                <a:ea typeface="Calibri" pitchFamily="34" charset="-122"/>
-                <a:cs typeface="Calibri" pitchFamily="34" charset="-120"/>
-              </a:rPr>
-              <a:t>Etiquetar: segura o insegura</a:t>
-            </a:r>
-            <a:endParaRPr lang="en-US" sz="1100" dirty="0"/>
-          </a:p>
-        </p:txBody>
-      </p:sp>
-      <p:sp>
-        <p:nvSpPr>
-          <p:cNvPr id="42" name="obj211"/>
-          <p:cNvSpPr/>
-          <p:nvPr/>
-        </p:nvSpPr>
-        <p:spPr>
-          <a:xfrm>
-            <a:off x="8092440" y="2624328"/>
-            <a:ext cx="402336" cy="402336"/>
-          </a:xfrm>
-          <a:prstGeom prst="roundRect">
-            <a:avLst>
-              <a:gd name="adj" fmla="val 50000"/>
-            </a:avLst>
-          </a:prstGeom>
-          <a:solidFill>
-            <a:srgbClr val="F2643D">
-              <a:alpha val="65000"/>
-            </a:srgbClr>
-          </a:solidFill>
-          <a:ln/>
-        </p:spPr>
-      </p:sp>
-      <p:sp>
-        <p:nvSpPr>
-          <p:cNvPr id="43" name="obj212"/>
-          <p:cNvSpPr txBox="1"/>
-          <p:nvPr/>
-        </p:nvSpPr>
-        <p:spPr>
-          <a:xfrm>
-            <a:off x="8092440" y="2624328"/>
-            <a:ext cx="402336" cy="402336"/>
-          </a:xfrm>
-          <a:prstGeom prst="rect">
-            <a:avLst/>
-          </a:prstGeom>
-          <a:noFill/>
-          <a:ln/>
-        </p:spPr>
-        <p:txBody>
-          <a:bodyPr wrap="square" lIns="0" tIns="0" rIns="0" bIns="0" rtlCol="0" anchor="ctr"/>
-          <a:lstStyle/>
-          <a:p>
-            <a:pPr algn="ctr" indent="0" marL="0">
-              <a:buNone/>
-            </a:pPr>
-            <a:r>
-              <a:rPr lang="en-US" sz="1600" b="1" dirty="0">
-                <a:solidFill>
-                  <a:srgbClr val="FFFFFF"/>
-                </a:solidFill>
-                <a:latin typeface="Calibri" pitchFamily="34" charset="0"/>
-                <a:ea typeface="Calibri" pitchFamily="34" charset="-122"/>
-                <a:cs typeface="Calibri" pitchFamily="34" charset="-120"/>
-              </a:rPr>
-              <a:t>3</a:t>
-            </a:r>
-            <a:endParaRPr lang="en-US" sz="1600" dirty="0"/>
-          </a:p>
-        </p:txBody>
-      </p:sp>
-      <p:sp>
-        <p:nvSpPr>
-          <p:cNvPr id="44" name="obj213"/>
-          <p:cNvSpPr/>
-          <p:nvPr/>
-        </p:nvSpPr>
-        <p:spPr>
-          <a:xfrm>
-            <a:off x="548640" y="3419856"/>
-            <a:ext cx="1874520" cy="914400"/>
-          </a:xfrm>
-          <a:prstGeom prst="roundRect">
-            <a:avLst>
-              <a:gd name="adj" fmla="val 14000"/>
-            </a:avLst>
-          </a:prstGeom>
-          <a:solidFill>
-            <a:srgbClr val="F4F4F2"/>
-          </a:solidFill>
-          <a:ln/>
-        </p:spPr>
-      </p:sp>
-      <p:sp>
-        <p:nvSpPr>
-          <p:cNvPr id="45" name="obj214"/>
-          <p:cNvSpPr txBox="1"/>
-          <p:nvPr/>
-        </p:nvSpPr>
-        <p:spPr>
-          <a:xfrm>
-            <a:off x="685800" y="3511296"/>
-            <a:ext cx="1188720" cy="228600"/>
-          </a:xfrm>
-          <a:prstGeom prst="rect">
-            <a:avLst/>
-          </a:prstGeom>
-          <a:noFill/>
-          <a:ln/>
-        </p:spPr>
-        <p:txBody>
-          <a:bodyPr wrap="square" lIns="0" tIns="0" rIns="0" bIns="0" rtlCol="0" anchor="t"/>
-          <a:lstStyle/>
-          <a:p>
-            <a:pPr algn="l" indent="0" marL="0">
-              <a:buNone/>
-            </a:pPr>
-            <a:r>
-              <a:rPr lang="en-US" sz="1100" b="1" dirty="0">
-                <a:solidFill>
-                  <a:srgbClr val="F2643D"/>
-                </a:solidFill>
-                <a:latin typeface="Calibri" pitchFamily="34" charset="0"/>
-                <a:ea typeface="Calibri" pitchFamily="34" charset="-122"/>
-                <a:cs typeface="Calibri" pitchFamily="34" charset="-120"/>
-              </a:rPr>
-              <a:t>HU09</a:t>
-            </a:r>
-            <a:pPr algn="l" indent="0" marL="0">
-              <a:buNone/>
-            </a:pPr>
-            <a:r>
-              <a:rPr lang="en-US" sz="1100" dirty="0">
-                <a:solidFill>
-                  <a:srgbClr val="F2643D"/>
-                </a:solidFill>
-                <a:latin typeface="Calibri" pitchFamily="34" charset="0"/>
-                <a:ea typeface="Calibri" pitchFamily="34" charset="-122"/>
-                <a:cs typeface="Calibri" pitchFamily="34" charset="-120"/>
-              </a:rPr>
-              <a:t> · EP05</a:t>
-            </a:r>
-            <a:endParaRPr lang="en-US" sz="1100" dirty="0"/>
-          </a:p>
-        </p:txBody>
-      </p:sp>
-      <p:sp>
-        <p:nvSpPr>
-          <p:cNvPr id="46" name="obj215"/>
-          <p:cNvSpPr txBox="1"/>
-          <p:nvPr/>
-        </p:nvSpPr>
-        <p:spPr>
-          <a:xfrm>
-            <a:off x="685800" y="3749040"/>
-            <a:ext cx="1207008" cy="530352"/>
-          </a:xfrm>
-          <a:prstGeom prst="rect">
-            <a:avLst/>
-          </a:prstGeom>
-          <a:noFill/>
-          <a:ln/>
-        </p:spPr>
-        <p:txBody>
-          <a:bodyPr wrap="square" lIns="0" tIns="0" rIns="0" bIns="0" rtlCol="0" anchor="t"/>
-          <a:lstStyle/>
-          <a:p>
-            <a:pPr algn="l" indent="0" marL="0">
-              <a:buNone/>
-            </a:pPr>
-            <a:r>
-              <a:rPr lang="en-US" sz="1100" dirty="0">
-                <a:solidFill>
-                  <a:srgbClr val="1F2421"/>
-                </a:solidFill>
-                <a:latin typeface="Calibri" pitchFamily="34" charset="0"/>
-                <a:ea typeface="Calibri" pitchFamily="34" charset="-122"/>
-                <a:cs typeface="Calibri" pitchFamily="34" charset="-120"/>
-              </a:rPr>
-              <a:t>Ver el video con recuadro de riesgo</a:t>
-            </a:r>
-            <a:endParaRPr lang="en-US" sz="1100" dirty="0"/>
-          </a:p>
-        </p:txBody>
-      </p:sp>
-      <p:sp>
-        <p:nvSpPr>
-          <p:cNvPr id="47" name="obj216"/>
-          <p:cNvSpPr/>
-          <p:nvPr/>
-        </p:nvSpPr>
-        <p:spPr>
-          <a:xfrm>
-            <a:off x="1920240" y="3648456"/>
-            <a:ext cx="402336" cy="402336"/>
-          </a:xfrm>
-          <a:prstGeom prst="roundRect">
-            <a:avLst>
-              <a:gd name="adj" fmla="val 50000"/>
-            </a:avLst>
-          </a:prstGeom>
-          <a:solidFill>
-            <a:srgbClr val="F2643D">
-              <a:alpha val="65000"/>
-            </a:srgbClr>
-          </a:solidFill>
-          <a:ln/>
-        </p:spPr>
-      </p:sp>
-      <p:sp>
-        <p:nvSpPr>
-          <p:cNvPr id="48" name="obj217"/>
-          <p:cNvSpPr txBox="1"/>
-          <p:nvPr/>
-        </p:nvSpPr>
-        <p:spPr>
-          <a:xfrm>
-            <a:off x="1920240" y="3648456"/>
-            <a:ext cx="402336" cy="402336"/>
-          </a:xfrm>
-          <a:prstGeom prst="rect">
-            <a:avLst/>
-          </a:prstGeom>
-          <a:noFill/>
-          <a:ln/>
-        </p:spPr>
-        <p:txBody>
-          <a:bodyPr wrap="square" lIns="0" tIns="0" rIns="0" bIns="0" rtlCol="0" anchor="ctr"/>
-          <a:lstStyle/>
-          <a:p>
-            <a:pPr algn="ctr" indent="0" marL="0">
-              <a:buNone/>
-            </a:pPr>
-            <a:r>
-              <a:rPr lang="en-US" sz="1600" b="1" dirty="0">
-                <a:solidFill>
-                  <a:srgbClr val="FFFFFF"/>
-                </a:solidFill>
-                <a:latin typeface="Calibri" pitchFamily="34" charset="0"/>
-                <a:ea typeface="Calibri" pitchFamily="34" charset="-122"/>
-                <a:cs typeface="Calibri" pitchFamily="34" charset="-120"/>
-              </a:rPr>
-              <a:t>3</a:t>
-            </a:r>
-            <a:endParaRPr lang="en-US" sz="1600" dirty="0"/>
-          </a:p>
-        </p:txBody>
-      </p:sp>
-      <p:sp>
-        <p:nvSpPr>
-          <p:cNvPr id="49" name="obj218"/>
-          <p:cNvSpPr/>
-          <p:nvPr/>
-        </p:nvSpPr>
-        <p:spPr>
-          <a:xfrm>
-            <a:off x="2606040" y="3419856"/>
-            <a:ext cx="1874520" cy="914400"/>
-          </a:xfrm>
-          <a:prstGeom prst="roundRect">
-            <a:avLst>
-              <a:gd name="adj" fmla="val 14000"/>
-            </a:avLst>
-          </a:prstGeom>
-          <a:solidFill>
-            <a:srgbClr val="F4F4F2"/>
-          </a:solidFill>
-          <a:ln/>
-        </p:spPr>
-      </p:sp>
-      <p:sp>
-        <p:nvSpPr>
-          <p:cNvPr id="50" name="obj219"/>
-          <p:cNvSpPr txBox="1"/>
-          <p:nvPr/>
-        </p:nvSpPr>
-        <p:spPr>
-          <a:xfrm>
-            <a:off x="2743200" y="3511296"/>
-            <a:ext cx="1188720" cy="228600"/>
-          </a:xfrm>
-          <a:prstGeom prst="rect">
-            <a:avLst/>
-          </a:prstGeom>
-          <a:noFill/>
-          <a:ln/>
-        </p:spPr>
-        <p:txBody>
-          <a:bodyPr wrap="square" lIns="0" tIns="0" rIns="0" bIns="0" rtlCol="0" anchor="t"/>
-          <a:lstStyle/>
-          <a:p>
-            <a:pPr algn="l" indent="0" marL="0">
-              <a:buNone/>
-            </a:pPr>
-            <a:r>
-              <a:rPr lang="en-US" sz="1100" b="1" dirty="0">
-                <a:solidFill>
-                  <a:srgbClr val="F2643D"/>
-                </a:solidFill>
-                <a:latin typeface="Calibri" pitchFamily="34" charset="0"/>
-                <a:ea typeface="Calibri" pitchFamily="34" charset="-122"/>
-                <a:cs typeface="Calibri" pitchFamily="34" charset="-120"/>
-              </a:rPr>
-              <a:t>HU10</a:t>
-            </a:r>
-            <a:pPr algn="l" indent="0" marL="0">
-              <a:buNone/>
-            </a:pPr>
-            <a:r>
-              <a:rPr lang="en-US" sz="1100" dirty="0">
-                <a:solidFill>
-                  <a:srgbClr val="F2643D"/>
-                </a:solidFill>
-                <a:latin typeface="Calibri" pitchFamily="34" charset="0"/>
-                <a:ea typeface="Calibri" pitchFamily="34" charset="-122"/>
-                <a:cs typeface="Calibri" pitchFamily="34" charset="-120"/>
-              </a:rPr>
-              <a:t> · EP05</a:t>
-            </a:r>
-            <a:endParaRPr lang="en-US" sz="1100" dirty="0"/>
-          </a:p>
-        </p:txBody>
-      </p:sp>
-      <p:sp>
-        <p:nvSpPr>
-          <p:cNvPr id="51" name="obj220"/>
-          <p:cNvSpPr txBox="1"/>
-          <p:nvPr/>
-        </p:nvSpPr>
-        <p:spPr>
-          <a:xfrm>
-            <a:off x="2743200" y="3749040"/>
-            <a:ext cx="1207008" cy="530352"/>
-          </a:xfrm>
-          <a:prstGeom prst="rect">
-            <a:avLst/>
-          </a:prstGeom>
-          <a:noFill/>
-          <a:ln/>
-        </p:spPr>
-        <p:txBody>
-          <a:bodyPr wrap="square" lIns="0" tIns="0" rIns="0" bIns="0" rtlCol="0" anchor="t"/>
-          <a:lstStyle/>
-          <a:p>
-            <a:pPr algn="l" indent="0" marL="0">
-              <a:buNone/>
-            </a:pPr>
-            <a:r>
-              <a:rPr lang="en-US" sz="1100" dirty="0">
-                <a:solidFill>
-                  <a:srgbClr val="1F2421"/>
-                </a:solidFill>
-                <a:latin typeface="Calibri" pitchFamily="34" charset="0"/>
-                <a:ea typeface="Calibri" pitchFamily="34" charset="-122"/>
-                <a:cs typeface="Calibri" pitchFamily="34" charset="-120"/>
-              </a:rPr>
-              <a:t>Activar la alerta</a:t>
-            </a:r>
-            <a:endParaRPr lang="en-US" sz="1100" dirty="0"/>
-          </a:p>
-        </p:txBody>
-      </p:sp>
-      <p:sp>
-        <p:nvSpPr>
-          <p:cNvPr id="52" name="obj221"/>
-          <p:cNvSpPr/>
-          <p:nvPr/>
-        </p:nvSpPr>
-        <p:spPr>
-          <a:xfrm>
-            <a:off x="3977640" y="3648456"/>
-            <a:ext cx="402336" cy="402336"/>
-          </a:xfrm>
-          <a:prstGeom prst="roundRect">
-            <a:avLst>
-              <a:gd name="adj" fmla="val 50000"/>
-            </a:avLst>
-          </a:prstGeom>
-          <a:solidFill>
-            <a:srgbClr val="F2643D">
-              <a:alpha val="45000"/>
-            </a:srgbClr>
-          </a:solidFill>
-          <a:ln/>
-        </p:spPr>
-      </p:sp>
-      <p:sp>
-        <p:nvSpPr>
-          <p:cNvPr id="53" name="obj222"/>
-          <p:cNvSpPr txBox="1"/>
-          <p:nvPr/>
-        </p:nvSpPr>
-        <p:spPr>
-          <a:xfrm>
-            <a:off x="3977640" y="3648456"/>
-            <a:ext cx="402336" cy="402336"/>
-          </a:xfrm>
-          <a:prstGeom prst="rect">
-            <a:avLst/>
-          </a:prstGeom>
-          <a:noFill/>
-          <a:ln/>
-        </p:spPr>
-        <p:txBody>
-          <a:bodyPr wrap="square" lIns="0" tIns="0" rIns="0" bIns="0" rtlCol="0" anchor="ctr"/>
-          <a:lstStyle/>
-          <a:p>
-            <a:pPr algn="ctr" indent="0" marL="0">
-              <a:buNone/>
-            </a:pPr>
-            <a:r>
-              <a:rPr lang="en-US" sz="1600" b="1" dirty="0">
-                <a:solidFill>
-                  <a:srgbClr val="1F2421"/>
-                </a:solidFill>
-                <a:latin typeface="Calibri" pitchFamily="34" charset="0"/>
-                <a:ea typeface="Calibri" pitchFamily="34" charset="-122"/>
-                <a:cs typeface="Calibri" pitchFamily="34" charset="-120"/>
-              </a:rPr>
-              <a:t>2</a:t>
-            </a:r>
-            <a:endParaRPr lang="en-US" sz="1600" dirty="0"/>
-          </a:p>
-        </p:txBody>
-      </p:sp>
-      <p:sp>
-        <p:nvSpPr>
-          <p:cNvPr id="54" name="obj223"/>
-          <p:cNvSpPr/>
-          <p:nvPr/>
-        </p:nvSpPr>
-        <p:spPr>
-          <a:xfrm>
-            <a:off x="4663440" y="3419856"/>
-            <a:ext cx="1874520" cy="914400"/>
-          </a:xfrm>
-          <a:prstGeom prst="roundRect">
-            <a:avLst>
-              <a:gd name="adj" fmla="val 14000"/>
-            </a:avLst>
-          </a:prstGeom>
-          <a:solidFill>
-            <a:srgbClr val="F4F4F2"/>
-          </a:solidFill>
-          <a:ln/>
-        </p:spPr>
-      </p:sp>
-      <p:sp>
-        <p:nvSpPr>
-          <p:cNvPr id="55" name="obj224"/>
-          <p:cNvSpPr txBox="1"/>
-          <p:nvPr/>
-        </p:nvSpPr>
-        <p:spPr>
-          <a:xfrm>
-            <a:off x="4800600" y="3511296"/>
-            <a:ext cx="1188720" cy="228600"/>
-          </a:xfrm>
-          <a:prstGeom prst="rect">
-            <a:avLst/>
-          </a:prstGeom>
-          <a:noFill/>
-          <a:ln/>
-        </p:spPr>
-        <p:txBody>
-          <a:bodyPr wrap="square" lIns="0" tIns="0" rIns="0" bIns="0" rtlCol="0" anchor="t"/>
-          <a:lstStyle/>
-          <a:p>
-            <a:pPr algn="l" indent="0" marL="0">
-              <a:buNone/>
-            </a:pPr>
-            <a:r>
-              <a:rPr lang="en-US" sz="1100" b="1" dirty="0">
-                <a:solidFill>
-                  <a:srgbClr val="F2643D"/>
-                </a:solidFill>
-                <a:latin typeface="Calibri" pitchFamily="34" charset="0"/>
-                <a:ea typeface="Calibri" pitchFamily="34" charset="-122"/>
-                <a:cs typeface="Calibri" pitchFamily="34" charset="-120"/>
-              </a:rPr>
-              <a:t>HU11</a:t>
-            </a:r>
-            <a:pPr algn="l" indent="0" marL="0">
-              <a:buNone/>
-            </a:pPr>
-            <a:r>
-              <a:rPr lang="en-US" sz="1100" dirty="0">
-                <a:solidFill>
-                  <a:srgbClr val="F2643D"/>
-                </a:solidFill>
-                <a:latin typeface="Calibri" pitchFamily="34" charset="0"/>
-                <a:ea typeface="Calibri" pitchFamily="34" charset="-122"/>
-                <a:cs typeface="Calibri" pitchFamily="34" charset="-120"/>
-              </a:rPr>
-              <a:t> · EP06</a:t>
-            </a:r>
-            <a:endParaRPr lang="en-US" sz="1100" dirty="0"/>
-          </a:p>
-        </p:txBody>
-      </p:sp>
-      <p:sp>
-        <p:nvSpPr>
-          <p:cNvPr id="56" name="obj225"/>
-          <p:cNvSpPr txBox="1"/>
-          <p:nvPr/>
-        </p:nvSpPr>
-        <p:spPr>
-          <a:xfrm>
-            <a:off x="4800600" y="3749040"/>
-            <a:ext cx="1207008" cy="530352"/>
-          </a:xfrm>
-          <a:prstGeom prst="rect">
-            <a:avLst/>
-          </a:prstGeom>
-          <a:noFill/>
-          <a:ln/>
-        </p:spPr>
-        <p:txBody>
-          <a:bodyPr wrap="square" lIns="0" tIns="0" rIns="0" bIns="0" rtlCol="0" anchor="t"/>
-          <a:lstStyle/>
-          <a:p>
-            <a:pPr algn="l" indent="0" marL="0">
-              <a:buNone/>
-            </a:pPr>
-            <a:r>
-              <a:rPr lang="en-US" sz="1100" dirty="0">
-                <a:solidFill>
-                  <a:srgbClr val="1F2421"/>
-                </a:solidFill>
-                <a:latin typeface="Calibri" pitchFamily="34" charset="0"/>
-                <a:ea typeface="Calibri" pitchFamily="34" charset="-122"/>
-                <a:cs typeface="Calibri" pitchFamily="34" charset="-120"/>
-              </a:rPr>
-              <a:t>Ajustar el umbral de YOLOv4</a:t>
-            </a:r>
-            <a:endParaRPr lang="en-US" sz="1100" dirty="0"/>
-          </a:p>
-        </p:txBody>
-      </p:sp>
-      <p:sp>
-        <p:nvSpPr>
-          <p:cNvPr id="57" name="obj226"/>
-          <p:cNvSpPr/>
-          <p:nvPr/>
-        </p:nvSpPr>
-        <p:spPr>
-          <a:xfrm>
-            <a:off x="6035040" y="3648456"/>
-            <a:ext cx="402336" cy="402336"/>
-          </a:xfrm>
-          <a:prstGeom prst="roundRect">
-            <a:avLst>
-              <a:gd name="adj" fmla="val 50000"/>
-            </a:avLst>
-          </a:prstGeom>
-          <a:solidFill>
-            <a:srgbClr val="F2643D">
-              <a:alpha val="28000"/>
-            </a:srgbClr>
-          </a:solidFill>
-          <a:ln/>
-        </p:spPr>
-      </p:sp>
-      <p:sp>
-        <p:nvSpPr>
-          <p:cNvPr id="58" name="obj227"/>
-          <p:cNvSpPr txBox="1"/>
-          <p:nvPr/>
-        </p:nvSpPr>
-        <p:spPr>
-          <a:xfrm>
-            <a:off x="6035040" y="3648456"/>
-            <a:ext cx="402336" cy="402336"/>
-          </a:xfrm>
-          <a:prstGeom prst="rect">
-            <a:avLst/>
-          </a:prstGeom>
-          <a:noFill/>
-          <a:ln/>
-        </p:spPr>
-        <p:txBody>
-          <a:bodyPr wrap="square" lIns="0" tIns="0" rIns="0" bIns="0" rtlCol="0" anchor="ctr"/>
-          <a:lstStyle/>
-          <a:p>
-            <a:pPr algn="ctr" indent="0" marL="0">
-              <a:buNone/>
-            </a:pPr>
-            <a:r>
-              <a:rPr lang="en-US" sz="1600" b="1" dirty="0">
-                <a:solidFill>
-                  <a:srgbClr val="1F2421"/>
-                </a:solidFill>
-                <a:latin typeface="Calibri" pitchFamily="34" charset="0"/>
-                <a:ea typeface="Calibri" pitchFamily="34" charset="-122"/>
-                <a:cs typeface="Calibri" pitchFamily="34" charset="-120"/>
-              </a:rPr>
-              <a:t>1</a:t>
-            </a:r>
-            <a:endParaRPr lang="en-US" sz="1600" dirty="0"/>
-          </a:p>
-        </p:txBody>
-      </p:sp>
-      <p:sp>
-        <p:nvSpPr>
-          <p:cNvPr id="59" name="obj228"/>
-          <p:cNvSpPr/>
-          <p:nvPr/>
-        </p:nvSpPr>
-        <p:spPr>
-          <a:xfrm>
-            <a:off x="6720840" y="3419856"/>
-            <a:ext cx="1874520" cy="914400"/>
-          </a:xfrm>
-          <a:prstGeom prst="roundRect">
-            <a:avLst>
-              <a:gd name="adj" fmla="val 14000"/>
-            </a:avLst>
-          </a:prstGeom>
-          <a:solidFill>
-            <a:srgbClr val="F4F4F2"/>
-          </a:solidFill>
-          <a:ln/>
-        </p:spPr>
-      </p:sp>
-      <p:sp>
-        <p:nvSpPr>
-          <p:cNvPr id="60" name="obj229"/>
-          <p:cNvSpPr txBox="1"/>
-          <p:nvPr/>
-        </p:nvSpPr>
-        <p:spPr>
-          <a:xfrm>
-            <a:off x="6858000" y="3511296"/>
-            <a:ext cx="1188720" cy="228600"/>
-          </a:xfrm>
-          <a:prstGeom prst="rect">
-            <a:avLst/>
-          </a:prstGeom>
-          <a:noFill/>
-          <a:ln/>
-        </p:spPr>
-        <p:txBody>
-          <a:bodyPr wrap="square" lIns="0" tIns="0" rIns="0" bIns="0" rtlCol="0" anchor="t"/>
-          <a:lstStyle/>
-          <a:p>
-            <a:pPr algn="l" indent="0" marL="0">
-              <a:buNone/>
-            </a:pPr>
-            <a:r>
-              <a:rPr lang="en-US" sz="1100" b="1" dirty="0">
-                <a:solidFill>
-                  <a:srgbClr val="F2643D"/>
-                </a:solidFill>
-                <a:latin typeface="Calibri" pitchFamily="34" charset="0"/>
-                <a:ea typeface="Calibri" pitchFamily="34" charset="-122"/>
-                <a:cs typeface="Calibri" pitchFamily="34" charset="-120"/>
-              </a:rPr>
-              <a:t>HU12</a:t>
-            </a:r>
-            <a:pPr algn="l" indent="0" marL="0">
-              <a:buNone/>
-            </a:pPr>
-            <a:r>
-              <a:rPr lang="en-US" sz="1100" dirty="0">
-                <a:solidFill>
-                  <a:srgbClr val="F2643D"/>
-                </a:solidFill>
-                <a:latin typeface="Calibri" pitchFamily="34" charset="0"/>
-                <a:ea typeface="Calibri" pitchFamily="34" charset="-122"/>
-                <a:cs typeface="Calibri" pitchFamily="34" charset="-120"/>
-              </a:rPr>
-              <a:t> · EP06</a:t>
-            </a:r>
-            <a:endParaRPr lang="en-US" sz="1100" dirty="0"/>
-          </a:p>
-        </p:txBody>
-      </p:sp>
-      <p:sp>
-        <p:nvSpPr>
-          <p:cNvPr id="61" name="obj230"/>
-          <p:cNvSpPr txBox="1"/>
-          <p:nvPr/>
-        </p:nvSpPr>
-        <p:spPr>
-          <a:xfrm>
-            <a:off x="6858000" y="3749040"/>
-            <a:ext cx="1207008" cy="530352"/>
-          </a:xfrm>
-          <a:prstGeom prst="rect">
-            <a:avLst/>
-          </a:prstGeom>
-          <a:noFill/>
-          <a:ln/>
-        </p:spPr>
-        <p:txBody>
-          <a:bodyPr wrap="square" lIns="0" tIns="0" rIns="0" bIns="0" rtlCol="0" anchor="t"/>
-          <a:lstStyle/>
-          <a:p>
-            <a:pPr algn="l" indent="0" marL="0">
-              <a:buNone/>
-            </a:pPr>
-            <a:r>
-              <a:rPr lang="en-US" sz="1100" dirty="0">
-                <a:solidFill>
-                  <a:srgbClr val="1F2421"/>
-                </a:solidFill>
-                <a:latin typeface="Calibri" pitchFamily="34" charset="0"/>
-                <a:ea typeface="Calibri" pitchFamily="34" charset="-122"/>
-                <a:cs typeface="Calibri" pitchFamily="34" charset="-120"/>
-              </a:rPr>
-              <a:t>Ver el log de tiempos</a:t>
-            </a:r>
-            <a:endParaRPr lang="en-US" sz="1100" dirty="0"/>
-          </a:p>
-        </p:txBody>
-      </p:sp>
-      <p:sp>
-        <p:nvSpPr>
-          <p:cNvPr id="62" name="obj231"/>
-          <p:cNvSpPr/>
+          <p:cNvPr id="63" name="obj232"/>
+          <p:cNvSpPr txBox="1"/>
           <p:nvPr/>
         </p:nvSpPr>
         <p:spPr>
@@ -9536,30 +9558,6 @@
             <a:off x="8092440" y="3648456"/>
             <a:ext cx="402336" cy="402336"/>
           </a:xfrm>
-          <a:prstGeom prst="roundRect">
-            <a:avLst>
-              <a:gd name="adj" fmla="val 50000"/>
-            </a:avLst>
-          </a:prstGeom>
-          <a:solidFill>
-            <a:srgbClr val="F2643D">
-              <a:alpha val="45000"/>
-            </a:srgbClr>
-          </a:solidFill>
-          <a:ln/>
-        </p:spPr>
-      </p:sp>
-      <p:sp>
-        <p:nvSpPr>
-          <p:cNvPr id="63" name="obj232"/>
-          <p:cNvSpPr txBox="1"/>
-          <p:nvPr/>
-        </p:nvSpPr>
-        <p:spPr>
-          <a:xfrm>
-            <a:off x="8092440" y="3648456"/>
-            <a:ext cx="402336" cy="402336"/>
-          </a:xfrm>
           <a:prstGeom prst="rect">
             <a:avLst/>
           </a:prstGeom>
@@ -9635,7 +9633,7 @@
                 <a:ea typeface="Calibri" pitchFamily="34" charset="-122"/>
                 <a:cs typeface="Calibri" pitchFamily="34" charset="-120"/>
               </a:rPr>
-              <a:t>la EP04 (ConvLSTM) concentra el mayor esfuerzo; las historias de carga y configuración son pequeñas. Votos simulados.</a:t>
+              <a:t>la EP04 (ConvLSTM) concentra el mayor esfuerzo; las historias de carga y configuración son pequeñas. Votos consensuados.</a:t>
             </a:r>
             <a:endParaRPr lang="en-US" sz="1100" dirty="0"/>
           </a:p>
@@ -9888,7 +9886,7 @@
                 <a:ea typeface="Calibri" pitchFamily="34" charset="-122"/>
                 <a:cs typeface="Calibri" pitchFamily="34" charset="-120"/>
               </a:rPr>
-              <a:t>¿EP01 (HU01–HU02) entra completa al Sprint 1?</a:t>
+              <a:t>¿HU01 a HU03 entran al Sprint 1 (7 pts)?</a:t>
             </a:r>
             <a:endParaRPr lang="en-US" sz="1300" dirty="0"/>
           </a:p>
@@ -10659,7 +10657,7 @@
                 <a:ea typeface="Calibri" pitchFamily="34" charset="-122"/>
                 <a:cs typeface="Calibri" pitchFamily="34" charset="-120"/>
               </a:rPr>
-              <a:t>¿EP02 y EP03 (HU03–HU06) juntas en el Sprint 2?</a:t>
+              <a:t>¿HU04, HU05, HU06 y HU11 al Sprint 2 (8 pts)?</a:t>
             </a:r>
             <a:endParaRPr lang="en-US" sz="1300" dirty="0"/>
           </a:p>
@@ -10682,7 +10680,7 @@
             </a:avLst>
           </a:prstGeom>
           <a:solidFill>
-            <a:srgbClr val="F0A020"/>
+            <a:srgbClr val="2F9E6E"/>
           </a:solidFill>
           <a:ln/>
         </p:spPr>
@@ -10704,7 +10702,7 @@
             </a:avLst>
           </a:prstGeom>
           <a:solidFill>
-            <a:srgbClr val="F0A020"/>
+            <a:srgbClr val="2F9E6E"/>
           </a:solidFill>
           <a:ln/>
         </p:spPr>
@@ -10726,7 +10724,7 @@
             </a:avLst>
           </a:prstGeom>
           <a:solidFill>
-            <a:srgbClr val="F0A020"/>
+            <a:srgbClr val="2F9E6E"/>
           </a:solidFill>
           <a:ln/>
         </p:spPr>
@@ -10739,8 +10737,8 @@
         </p:nvSpPr>
         <p:spPr>
           <a:xfrm>
-            <a:off x="5252314" y="2694554"/>
-            <a:ext cx="53767" cy="50694"/>
+            <a:off x="5252314" y="2597774"/>
+            <a:ext cx="53767" cy="147474"/>
           </a:xfrm>
           <a:prstGeom prst="roundRect">
             <a:avLst>
@@ -10748,9 +10746,7 @@
             </a:avLst>
           </a:prstGeom>
           <a:solidFill>
-            <a:srgbClr val="F0A020">
-              <a:alpha val="40000"/>
-            </a:srgbClr>
+            <a:srgbClr val="2F9E6E"/>
           </a:solidFill>
           <a:ln/>
         </p:spPr>
@@ -10772,7 +10768,7 @@
             </a:avLst>
           </a:prstGeom>
           <a:solidFill>
-            <a:srgbClr val="F0A020"/>
+            <a:srgbClr val="2F9E6E"/>
           </a:solidFill>
           <a:ln/>
         </p:spPr>
@@ -10804,13 +10800,13 @@
             <a:r>
               <a:rPr lang="en-US" sz="2400" b="1" dirty="0">
                 <a:solidFill>
-                  <a:srgbClr val="F0A020"/>
-                </a:solidFill>
-                <a:latin typeface="Calibri" pitchFamily="34" charset="0"/>
-                <a:ea typeface="Calibri" pitchFamily="34" charset="-122"/>
-                <a:cs typeface="Calibri" pitchFamily="34" charset="-120"/>
-              </a:rPr>
-              <a:t>3</a:t>
+                  <a:srgbClr val="2F9E6E"/>
+                </a:solidFill>
+                <a:latin typeface="Calibri" pitchFamily="34" charset="0"/>
+                <a:ea typeface="Calibri" pitchFamily="34" charset="-122"/>
+                <a:cs typeface="Calibri" pitchFamily="34" charset="-120"/>
+              </a:rPr>
+              <a:t>4</a:t>
             </a:r>
             <a:endParaRPr lang="en-US" sz="2400" dirty="0"/>
           </a:p>
@@ -11060,7 +11056,7 @@
             </a:avLst>
           </a:prstGeom>
           <a:solidFill>
-            <a:srgbClr val="F0A020"/>
+            <a:srgbClr val="2F9E6E"/>
           </a:solidFill>
           <a:ln/>
         </p:spPr>
@@ -11082,7 +11078,7 @@
             </a:avLst>
           </a:prstGeom>
           <a:solidFill>
-            <a:srgbClr val="F0A020"/>
+            <a:srgbClr val="2F9E6E"/>
           </a:solidFill>
           <a:ln/>
         </p:spPr>
@@ -11104,7 +11100,7 @@
             </a:avLst>
           </a:prstGeom>
           <a:solidFill>
-            <a:srgbClr val="F0A020"/>
+            <a:srgbClr val="2F9E6E"/>
           </a:solidFill>
           <a:ln/>
         </p:spPr>
@@ -11117,8 +11113,8 @@
         </p:nvSpPr>
         <p:spPr>
           <a:xfrm>
-            <a:off x="6934810" y="2694554"/>
-            <a:ext cx="53767" cy="50694"/>
+            <a:off x="6934810" y="2597774"/>
+            <a:ext cx="53767" cy="147474"/>
           </a:xfrm>
           <a:prstGeom prst="roundRect">
             <a:avLst>
@@ -11126,9 +11122,7 @@
             </a:avLst>
           </a:prstGeom>
           <a:solidFill>
-            <a:srgbClr val="F0A020">
-              <a:alpha val="40000"/>
-            </a:srgbClr>
+            <a:srgbClr val="2F9E6E"/>
           </a:solidFill>
           <a:ln/>
         </p:spPr>
@@ -11136,6 +11130,28 @@
       <p:sp>
         <p:nvSpPr>
           <p:cNvPr id="53" name="obj284"/>
+          <p:cNvSpPr/>
+          <p:nvPr/>
+        </p:nvSpPr>
+        <p:spPr>
+          <a:xfrm rot="-1920000">
+            <a:off x="6673657" y="2680728"/>
+            <a:ext cx="57607" cy="156692"/>
+          </a:xfrm>
+          <a:prstGeom prst="roundRect">
+            <a:avLst>
+              <a:gd name="adj" fmla="val 50000"/>
+            </a:avLst>
+          </a:prstGeom>
+          <a:solidFill>
+            <a:srgbClr val="2F9E6E"/>
+          </a:solidFill>
+          <a:ln/>
+        </p:spPr>
+      </p:sp>
+      <p:sp>
+        <p:nvSpPr>
+          <p:cNvPr id="54" name="obj285"/>
           <p:cNvSpPr/>
           <p:nvPr/>
         </p:nvSpPr>
@@ -11150,14 +11166,14 @@
             </a:avLst>
           </a:prstGeom>
           <a:solidFill>
-            <a:srgbClr val="F0A020"/>
-          </a:solidFill>
-          <a:ln/>
-        </p:spPr>
-      </p:sp>
-      <p:sp>
-        <p:nvSpPr>
-          <p:cNvPr id="54" name="obj285"/>
+            <a:srgbClr val="2F9E6E"/>
+          </a:solidFill>
+          <a:ln/>
+        </p:spPr>
+      </p:sp>
+      <p:sp>
+        <p:nvSpPr>
+          <p:cNvPr id="55" name="obj286"/>
           <p:cNvSpPr txBox="1"/>
           <p:nvPr/>
         </p:nvSpPr>
@@ -11182,13 +11198,13 @@
             <a:r>
               <a:rPr lang="en-US" sz="2400" b="1" dirty="0">
                 <a:solidFill>
-                  <a:srgbClr val="F0A020"/>
-                </a:solidFill>
-                <a:latin typeface="Calibri" pitchFamily="34" charset="0"/>
-                <a:ea typeface="Calibri" pitchFamily="34" charset="-122"/>
-                <a:cs typeface="Calibri" pitchFamily="34" charset="-120"/>
-              </a:rPr>
-              <a:t>3</a:t>
+                  <a:srgbClr val="2F9E6E"/>
+                </a:solidFill>
+                <a:latin typeface="Calibri" pitchFamily="34" charset="0"/>
+                <a:ea typeface="Calibri" pitchFamily="34" charset="-122"/>
+                <a:cs typeface="Calibri" pitchFamily="34" charset="-120"/>
+              </a:rPr>
+              <a:t>5</a:t>
             </a:r>
             <a:endParaRPr lang="en-US" sz="2400" dirty="0"/>
           </a:p>
@@ -11196,7 +11212,7 @@
       </p:sp>
       <p:sp>
         <p:nvSpPr>
-          <p:cNvPr id="55" name="obj286"/>
+          <p:cNvPr id="56" name="obj287"/>
           <p:cNvSpPr txBox="1"/>
           <p:nvPr/>
         </p:nvSpPr>
@@ -11235,7 +11251,7 @@
       </p:sp>
       <p:sp>
         <p:nvSpPr>
-          <p:cNvPr id="56" name="obj287"/>
+          <p:cNvPr id="57" name="obj288"/>
           <p:cNvSpPr/>
           <p:nvPr/>
         </p:nvSpPr>
@@ -11250,7 +11266,7 @@
             </a:avLst>
           </a:prstGeom>
           <a:solidFill>
-            <a:srgbClr val="F0A020">
+            <a:srgbClr val="2F9E6E">
               <a:alpha val="18000"/>
             </a:srgbClr>
           </a:solidFill>
@@ -11259,7 +11275,7 @@
       </p:sp>
       <p:sp>
         <p:nvSpPr>
-          <p:cNvPr id="57" name="obj288"/>
+          <p:cNvPr id="58" name="obj289"/>
           <p:cNvSpPr txBox="1"/>
           <p:nvPr/>
         </p:nvSpPr>
@@ -11290,7 +11306,7 @@
                 <a:ea typeface="Calibri" pitchFamily="34" charset="-122"/>
                 <a:cs typeface="Calibri" pitchFamily="34" charset="-120"/>
               </a:rPr>
-              <a:t>Sí, con revisión a mitad del sprint</a:t>
+              <a:t>Aprobado</a:t>
             </a:r>
             <a:endParaRPr lang="en-US" sz="1050" dirty="0"/>
           </a:p>
@@ -11298,7 +11314,7 @@
       </p:sp>
       <p:sp>
         <p:nvSpPr>
-          <p:cNvPr id="58" name="obj289"/>
+          <p:cNvPr id="59" name="obj290"/>
           <p:cNvSpPr/>
           <p:nvPr/>
         </p:nvSpPr>
@@ -11320,7 +11336,7 @@
       </p:sp>
       <p:sp>
         <p:nvSpPr>
-          <p:cNvPr id="59" name="obj290"/>
+          <p:cNvPr id="60" name="obj291"/>
           <p:cNvSpPr txBox="1"/>
           <p:nvPr/>
         </p:nvSpPr>
@@ -11359,7 +11375,7 @@
       </p:sp>
       <p:sp>
         <p:nvSpPr>
-          <p:cNvPr id="60" name="obj291"/>
+          <p:cNvPr id="61" name="obj292"/>
           <p:cNvSpPr txBox="1"/>
           <p:nvPr/>
         </p:nvSpPr>
@@ -11390,7 +11406,7 @@
                 <a:ea typeface="Calibri" pitchFamily="34" charset="-122"/>
                 <a:cs typeface="Calibri" pitchFamily="34" charset="-120"/>
               </a:rPr>
-              <a:t>¿EP05 y EP06 (HU09–HU12) quedan para el Sprint 4?</a:t>
+              <a:t>¿HU09, HU10 y HU12 quedan para el Sprint 4 (8 pts)?</a:t>
             </a:r>
             <a:endParaRPr lang="en-US" sz="1300" dirty="0"/>
           </a:p>
@@ -11398,7 +11414,7 @@
       </p:sp>
       <p:sp>
         <p:nvSpPr>
-          <p:cNvPr id="61" name="obj292"/>
+          <p:cNvPr id="62" name="obj293"/>
           <p:cNvSpPr/>
           <p:nvPr/>
         </p:nvSpPr>
@@ -11420,7 +11436,7 @@
       </p:sp>
       <p:sp>
         <p:nvSpPr>
-          <p:cNvPr id="62" name="obj293"/>
+          <p:cNvPr id="63" name="obj294"/>
           <p:cNvSpPr/>
           <p:nvPr/>
         </p:nvSpPr>
@@ -11442,7 +11458,7 @@
       </p:sp>
       <p:sp>
         <p:nvSpPr>
-          <p:cNvPr id="63" name="obj294"/>
+          <p:cNvPr id="64" name="obj295"/>
           <p:cNvSpPr/>
           <p:nvPr/>
         </p:nvSpPr>
@@ -11464,7 +11480,7 @@
       </p:sp>
       <p:sp>
         <p:nvSpPr>
-          <p:cNvPr id="64" name="obj295"/>
+          <p:cNvPr id="65" name="obj296"/>
           <p:cNvSpPr/>
           <p:nvPr/>
         </p:nvSpPr>
@@ -11486,7 +11502,7 @@
       </p:sp>
       <p:sp>
         <p:nvSpPr>
-          <p:cNvPr id="65" name="obj296"/>
+          <p:cNvPr id="66" name="obj297"/>
           <p:cNvSpPr/>
           <p:nvPr/>
         </p:nvSpPr>
@@ -11508,7 +11524,7 @@
       </p:sp>
       <p:sp>
         <p:nvSpPr>
-          <p:cNvPr id="66" name="obj297"/>
+          <p:cNvPr id="67" name="obj298"/>
           <p:cNvSpPr txBox="1"/>
           <p:nvPr/>
         </p:nvSpPr>
@@ -11547,7 +11563,7 @@
       </p:sp>
       <p:sp>
         <p:nvSpPr>
-          <p:cNvPr id="67" name="obj298"/>
+          <p:cNvPr id="68" name="obj299"/>
           <p:cNvSpPr txBox="1"/>
           <p:nvPr/>
         </p:nvSpPr>
@@ -11586,7 +11602,7 @@
       </p:sp>
       <p:sp>
         <p:nvSpPr>
-          <p:cNvPr id="68" name="obj299"/>
+          <p:cNvPr id="69" name="obj300"/>
           <p:cNvSpPr/>
           <p:nvPr/>
         </p:nvSpPr>
@@ -11608,7 +11624,7 @@
       </p:sp>
       <p:sp>
         <p:nvSpPr>
-          <p:cNvPr id="69" name="obj300"/>
+          <p:cNvPr id="70" name="obj301"/>
           <p:cNvSpPr/>
           <p:nvPr/>
         </p:nvSpPr>
@@ -11630,7 +11646,7 @@
       </p:sp>
       <p:sp>
         <p:nvSpPr>
-          <p:cNvPr id="70" name="obj301"/>
+          <p:cNvPr id="71" name="obj302"/>
           <p:cNvSpPr/>
           <p:nvPr/>
         </p:nvSpPr>
@@ -11652,7 +11668,7 @@
       </p:sp>
       <p:sp>
         <p:nvSpPr>
-          <p:cNvPr id="71" name="obj302"/>
+          <p:cNvPr id="72" name="obj303"/>
           <p:cNvSpPr/>
           <p:nvPr/>
         </p:nvSpPr>
@@ -11674,7 +11690,7 @@
       </p:sp>
       <p:sp>
         <p:nvSpPr>
-          <p:cNvPr id="72" name="obj303"/>
+          <p:cNvPr id="73" name="obj304"/>
           <p:cNvSpPr/>
           <p:nvPr/>
         </p:nvSpPr>
@@ -11696,7 +11712,7 @@
       </p:sp>
       <p:sp>
         <p:nvSpPr>
-          <p:cNvPr id="73" name="obj304"/>
+          <p:cNvPr id="74" name="obj305"/>
           <p:cNvSpPr/>
           <p:nvPr/>
         </p:nvSpPr>
@@ -11718,7 +11734,7 @@
       </p:sp>
       <p:sp>
         <p:nvSpPr>
-          <p:cNvPr id="74" name="obj305"/>
+          <p:cNvPr id="75" name="obj306"/>
           <p:cNvSpPr txBox="1"/>
           <p:nvPr/>
         </p:nvSpPr>
@@ -11757,7 +11773,7 @@
       </p:sp>
       <p:sp>
         <p:nvSpPr>
-          <p:cNvPr id="75" name="obj306"/>
+          <p:cNvPr id="76" name="obj307"/>
           <p:cNvSpPr txBox="1"/>
           <p:nvPr/>
         </p:nvSpPr>
@@ -11796,7 +11812,7 @@
       </p:sp>
       <p:sp>
         <p:nvSpPr>
-          <p:cNvPr id="76" name="obj307"/>
+          <p:cNvPr id="77" name="obj308"/>
           <p:cNvSpPr/>
           <p:nvPr/>
         </p:nvSpPr>
@@ -11818,7 +11834,7 @@
       </p:sp>
       <p:sp>
         <p:nvSpPr>
-          <p:cNvPr id="77" name="obj308"/>
+          <p:cNvPr id="78" name="obj309"/>
           <p:cNvSpPr/>
           <p:nvPr/>
         </p:nvSpPr>
@@ -11840,7 +11856,7 @@
       </p:sp>
       <p:sp>
         <p:nvSpPr>
-          <p:cNvPr id="78" name="obj309"/>
+          <p:cNvPr id="79" name="obj310"/>
           <p:cNvSpPr/>
           <p:nvPr/>
         </p:nvSpPr>
@@ -11862,7 +11878,7 @@
       </p:sp>
       <p:sp>
         <p:nvSpPr>
-          <p:cNvPr id="79" name="obj310"/>
+          <p:cNvPr id="80" name="obj311"/>
           <p:cNvSpPr/>
           <p:nvPr/>
         </p:nvSpPr>
@@ -11884,7 +11900,7 @@
       </p:sp>
       <p:sp>
         <p:nvSpPr>
-          <p:cNvPr id="80" name="obj311"/>
+          <p:cNvPr id="81" name="obj312"/>
           <p:cNvSpPr/>
           <p:nvPr/>
         </p:nvSpPr>
@@ -11906,7 +11922,7 @@
       </p:sp>
       <p:sp>
         <p:nvSpPr>
-          <p:cNvPr id="81" name="obj312"/>
+          <p:cNvPr id="82" name="obj313"/>
           <p:cNvSpPr txBox="1"/>
           <p:nvPr/>
         </p:nvSpPr>
@@ -11945,7 +11961,7 @@
       </p:sp>
       <p:sp>
         <p:nvSpPr>
-          <p:cNvPr id="82" name="obj313"/>
+          <p:cNvPr id="83" name="obj314"/>
           <p:cNvSpPr txBox="1"/>
           <p:nvPr/>
         </p:nvSpPr>
@@ -11984,7 +12000,7 @@
       </p:sp>
       <p:sp>
         <p:nvSpPr>
-          <p:cNvPr id="83" name="obj314"/>
+          <p:cNvPr id="84" name="obj315"/>
           <p:cNvSpPr/>
           <p:nvPr/>
         </p:nvSpPr>
@@ -12008,7 +12024,7 @@
       </p:sp>
       <p:sp>
         <p:nvSpPr>
-          <p:cNvPr id="84" name="obj315"/>
+          <p:cNvPr id="85" name="obj316"/>
           <p:cNvSpPr txBox="1"/>
           <p:nvPr/>
         </p:nvSpPr>
@@ -12047,7 +12063,7 @@
       </p:sp>
       <p:sp>
         <p:nvSpPr>
-          <p:cNvPr id="85" name="obj316"/>
+          <p:cNvPr id="86" name="obj317"/>
           <p:cNvSpPr txBox="1"/>
           <p:nvPr/>
         </p:nvSpPr>
@@ -12214,7 +12230,7 @@
       </p:sp>
       <p:graphicFrame>
         <p:nvGraphicFramePr>
-          <p:cNvPr id="9" name="obj317"/>
+          <p:cNvPr id="9" name="obj318"/>
           <p:cNvGraphicFramePr>
             <a:graphicFrameLocks noGrp="1"/>
           </p:cNvGraphicFramePr>
@@ -13275,7 +13291,7 @@
       </p:graphicFrame>
       <p:sp>
         <p:nvSpPr>
-          <p:cNvPr id="4" name="obj318"/>
+          <p:cNvPr id="4" name="obj319"/>
           <p:cNvSpPr/>
           <p:nvPr/>
         </p:nvSpPr>
@@ -13297,7 +13313,7 @@
       </p:sp>
       <p:sp>
         <p:nvSpPr>
-          <p:cNvPr id="5" name="obj319"/>
+          <p:cNvPr id="5" name="obj320"/>
           <p:cNvSpPr/>
           <p:nvPr/>
         </p:nvSpPr>
@@ -13319,7 +13335,7 @@
       </p:sp>
       <p:sp>
         <p:nvSpPr>
-          <p:cNvPr id="6" name="obj320"/>
+          <p:cNvPr id="6" name="obj321"/>
           <p:cNvSpPr/>
           <p:nvPr/>
         </p:nvSpPr>
@@ -13341,7 +13357,7 @@
       </p:sp>
       <p:sp>
         <p:nvSpPr>
-          <p:cNvPr id="7" name="obj321"/>
+          <p:cNvPr id="7" name="obj322"/>
           <p:cNvSpPr/>
           <p:nvPr/>
         </p:nvSpPr>
@@ -13363,7 +13379,7 @@
       </p:sp>
       <p:sp>
         <p:nvSpPr>
-          <p:cNvPr id="8" name="obj322"/>
+          <p:cNvPr id="8" name="obj323"/>
           <p:cNvSpPr/>
           <p:nvPr/>
         </p:nvSpPr>
@@ -13385,7 +13401,7 @@
       </p:sp>
       <p:sp>
         <p:nvSpPr>
-          <p:cNvPr id="9" name="obj323"/>
+          <p:cNvPr id="9" name="obj324"/>
           <p:cNvSpPr/>
           <p:nvPr/>
         </p:nvSpPr>
@@ -13407,7 +13423,7 @@
       </p:sp>
       <p:sp>
         <p:nvSpPr>
-          <p:cNvPr id="10" name="obj324"/>
+          <p:cNvPr id="10" name="obj325"/>
           <p:cNvSpPr/>
           <p:nvPr/>
         </p:nvSpPr>
@@ -13429,7 +13445,7 @@
       </p:sp>
       <p:sp>
         <p:nvSpPr>
-          <p:cNvPr id="11" name="obj325"/>
+          <p:cNvPr id="11" name="obj326"/>
           <p:cNvSpPr txBox="1"/>
           <p:nvPr/>
         </p:nvSpPr>
@@ -13468,7 +13484,7 @@
       </p:sp>
       <p:sp>
         <p:nvSpPr>
-          <p:cNvPr id="12" name="obj326"/>
+          <p:cNvPr id="12" name="obj327"/>
           <p:cNvSpPr txBox="1"/>
           <p:nvPr/>
         </p:nvSpPr>

</xml_diff>